<commit_message>
Rapport et présentation retravaillés (skills docx/pptx/rapport)
- Deck redessiné : structure sombre/clair, motif marge rouge, Georgia,
  chiffres clés, flux de sécurisation numéroté, numéros de diapositive.
- Rapport : titres Georgia encre, filet rouge de couverture, lien GitHub.
- Ajout des skills docx, pptx et rapport (pipeline de génération documenté).
</commit_message>
<xml_diff>
--- a/docs/Presentation.pptx
+++ b/docs/Presentation.pptx
@@ -3089,6 +3089,14 @@
 <file path=ppt/slides/slide1.xml><?xml version="1.0" encoding="utf-8"?>
 <p:sld xmlns:a="http://schemas.openxmlformats.org/drawingml/2006/main" xmlns:p="http://schemas.openxmlformats.org/presentationml/2006/main" xmlns:r="http://schemas.openxmlformats.org/officeDocument/2006/relationships">
   <p:cSld>
+    <p:bg>
+      <p:bgPr>
+        <a:solidFill>
+          <a:srgbClr val="16213A"/>
+        </a:solidFill>
+        <a:effectLst/>
+      </p:bgPr>
+    </p:bg>
     <p:spTree>
       <p:nvGrpSpPr>
         <p:cNvPr id="1" name=""/>
@@ -3098,14 +3106,58 @@
       <p:grpSpPr/>
       <p:sp>
         <p:nvSpPr>
-          <p:cNvPr id="2" name="TextBox 1"/>
+          <p:cNvPr id="2" name="Rectangle 1"/>
+          <p:cNvSpPr/>
+          <p:nvPr/>
+        </p:nvSpPr>
+        <p:spPr>
+          <a:xfrm>
+            <a:off x="502920" y="0"/>
+            <a:ext cx="32004" cy="6858000"/>
+          </a:xfrm>
+          <a:prstGeom prst="rect">
+            <a:avLst/>
+          </a:prstGeom>
+          <a:solidFill>
+            <a:srgbClr val="D8432F"/>
+          </a:solidFill>
+          <a:ln>
+            <a:noFill/>
+          </a:ln>
+          <a:effectLst/>
+        </p:spPr>
+        <p:style>
+          <a:lnRef idx="1">
+            <a:schemeClr val="accent1"/>
+          </a:lnRef>
+          <a:fillRef idx="3">
+            <a:schemeClr val="accent1"/>
+          </a:fillRef>
+          <a:effectRef idx="2">
+            <a:schemeClr val="accent1"/>
+          </a:effectRef>
+          <a:fontRef idx="minor">
+            <a:schemeClr val="lt1"/>
+          </a:fontRef>
+        </p:style>
+        <p:txBody>
+          <a:bodyPr rtlCol="0" anchor="ctr"/>
+          <a:lstStyle/>
+          <a:p>
+            <a:pPr algn="ctr"/>
+          </a:p>
+        </p:txBody>
+      </p:sp>
+      <p:sp>
+        <p:nvSpPr>
+          <p:cNvPr id="3" name="TextBox 2"/>
           <p:cNvSpPr txBox="1"/>
           <p:nvPr/>
         </p:nvSpPr>
         <p:spPr>
           <a:xfrm>
-            <a:off x="822960" y="2011680"/>
-            <a:ext cx="10515600" cy="2743200"/>
+            <a:off x="914400" y="1965960"/>
+            <a:ext cx="10424160" cy="365760"/>
           </a:xfrm>
           <a:prstGeom prst="rect">
             <a:avLst/>
@@ -3118,33 +3170,120 @@
           </a:bodyPr>
           <a:lstStyle/>
           <a:p>
-            <a:r>
-              <a:rPr sz="4000" b="1">
-                <a:solidFill>
-                  <a:srgbClr val="16213A"/>
-                </a:solidFill>
-              </a:rPr>
-              <a:t>EChallenge — Plateforme d'examens en ligne</a:t>
-            </a:r>
-          </a:p>
-          <a:p>
-            <a:r>
-              <a:rPr sz="2400">
+            <a:pPr algn="l"/>
+            <a:r>
+              <a:rPr sz="1400" b="1">
                 <a:solidFill>
                   <a:srgbClr val="D8432F"/>
                 </a:solidFill>
-              </a:rPr>
-              <a:t>Projet de Fin de Module — JEE / Spring Boot</a:t>
-            </a:r>
-          </a:p>
-          <a:p>
-            <a:r>
-              <a:rPr sz="1800">
-                <a:solidFill>
-                  <a:srgbClr val="68707F"/>
-                </a:solidFill>
-              </a:rPr>
-              <a:t>Mehdi Aichouch — 2026</a:t>
+                <a:latin typeface="Consolas"/>
+              </a:rPr>
+              <a:t>PROJET DE FIN DE MODULE — JEE / SPRING BOOT</a:t>
+            </a:r>
+          </a:p>
+        </p:txBody>
+      </p:sp>
+      <p:sp>
+        <p:nvSpPr>
+          <p:cNvPr id="4" name="TextBox 3"/>
+          <p:cNvSpPr txBox="1"/>
+          <p:nvPr/>
+        </p:nvSpPr>
+        <p:spPr>
+          <a:xfrm>
+            <a:off x="914400" y="2377440"/>
+            <a:ext cx="10424160" cy="1554480"/>
+          </a:xfrm>
+          <a:prstGeom prst="rect">
+            <a:avLst/>
+          </a:prstGeom>
+          <a:noFill/>
+        </p:spPr>
+        <p:txBody>
+          <a:bodyPr wrap="square">
+            <a:spAutoFit/>
+          </a:bodyPr>
+          <a:lstStyle/>
+          <a:p>
+            <a:pPr algn="l"/>
+            <a:r>
+              <a:rPr sz="6000" b="1">
+                <a:solidFill>
+                  <a:srgbClr val="FFFFFF"/>
+                </a:solidFill>
+                <a:latin typeface="Georgia"/>
+              </a:rPr>
+              <a:t>EChallenge</a:t>
+            </a:r>
+          </a:p>
+        </p:txBody>
+      </p:sp>
+      <p:sp>
+        <p:nvSpPr>
+          <p:cNvPr id="5" name="TextBox 4"/>
+          <p:cNvSpPr txBox="1"/>
+          <p:nvPr/>
+        </p:nvSpPr>
+        <p:spPr>
+          <a:xfrm>
+            <a:off x="914400" y="3429000"/>
+            <a:ext cx="10424160" cy="731520"/>
+          </a:xfrm>
+          <a:prstGeom prst="rect">
+            <a:avLst/>
+          </a:prstGeom>
+          <a:noFill/>
+        </p:spPr>
+        <p:txBody>
+          <a:bodyPr wrap="square">
+            <a:spAutoFit/>
+          </a:bodyPr>
+          <a:lstStyle/>
+          <a:p>
+            <a:pPr algn="l"/>
+            <a:r>
+              <a:rPr sz="2000" b="0">
+                <a:solidFill>
+                  <a:srgbClr val="C3CBDD"/>
+                </a:solidFill>
+                <a:latin typeface="Calibri"/>
+              </a:rPr>
+              <a:t>Plateforme d'examens en ligne — inscription, passage chronométré, notation automatique</a:t>
+            </a:r>
+          </a:p>
+        </p:txBody>
+      </p:sp>
+      <p:sp>
+        <p:nvSpPr>
+          <p:cNvPr id="6" name="TextBox 5"/>
+          <p:cNvSpPr txBox="1"/>
+          <p:nvPr/>
+        </p:nvSpPr>
+        <p:spPr>
+          <a:xfrm>
+            <a:off x="914400" y="4663440"/>
+            <a:ext cx="10424160" cy="457200"/>
+          </a:xfrm>
+          <a:prstGeom prst="rect">
+            <a:avLst/>
+          </a:prstGeom>
+          <a:noFill/>
+        </p:spPr>
+        <p:txBody>
+          <a:bodyPr wrap="square">
+            <a:spAutoFit/>
+          </a:bodyPr>
+          <a:lstStyle/>
+          <a:p>
+            <a:pPr algn="l"/>
+            <a:r>
+              <a:rPr sz="1500" b="0">
+                <a:solidFill>
+                  <a:srgbClr val="C3CBDD"/>
+                </a:solidFill>
+                <a:latin typeface="Calibri"/>
+              </a:rPr>
+              <a:t>Mehdi Aichouch  ·  2026</a:t>
             </a:r>
           </a:p>
         </p:txBody>
@@ -3160,6 +3299,14 @@
 <file path=ppt/slides/slide2.xml><?xml version="1.0" encoding="utf-8"?>
 <p:sld xmlns:a="http://schemas.openxmlformats.org/drawingml/2006/main" xmlns:p="http://schemas.openxmlformats.org/presentationml/2006/main" xmlns:r="http://schemas.openxmlformats.org/officeDocument/2006/relationships">
   <p:cSld>
+    <p:bg>
+      <p:bgPr>
+        <a:solidFill>
+          <a:srgbClr val="FBFAF6"/>
+        </a:solidFill>
+        <a:effectLst/>
+      </p:bgPr>
+    </p:bg>
     <p:spTree>
       <p:nvGrpSpPr>
         <p:cNvPr id="1" name=""/>
@@ -3169,34 +3316,45 @@
       <p:grpSpPr/>
       <p:sp>
         <p:nvSpPr>
-          <p:cNvPr id="2" name="TextBox 1"/>
-          <p:cNvSpPr txBox="1"/>
-          <p:nvPr/>
-        </p:nvSpPr>
-        <p:spPr>
-          <a:xfrm>
-            <a:off x="548640" y="320040"/>
-            <a:ext cx="11064240" cy="914400"/>
-          </a:xfrm>
-          <a:prstGeom prst="rect">
-            <a:avLst/>
-          </a:prstGeom>
-          <a:noFill/>
-        </p:spPr>
-        <p:txBody>
-          <a:bodyPr wrap="none">
-            <a:spAutoFit/>
-          </a:bodyPr>
-          <a:lstStyle/>
-          <a:p>
-            <a:r>
-              <a:rPr sz="3200" b="1">
-                <a:solidFill>
-                  <a:srgbClr val="16213A"/>
-                </a:solidFill>
-              </a:rPr>
-              <a:t>Contexte et objectifs</a:t>
-            </a:r>
+          <p:cNvPr id="2" name="Rectangle 1"/>
+          <p:cNvSpPr/>
+          <p:nvPr/>
+        </p:nvSpPr>
+        <p:spPr>
+          <a:xfrm>
+            <a:off x="502920" y="0"/>
+            <a:ext cx="32004" cy="6858000"/>
+          </a:xfrm>
+          <a:prstGeom prst="rect">
+            <a:avLst/>
+          </a:prstGeom>
+          <a:solidFill>
+            <a:srgbClr val="D8432F"/>
+          </a:solidFill>
+          <a:ln>
+            <a:noFill/>
+          </a:ln>
+          <a:effectLst/>
+        </p:spPr>
+        <p:style>
+          <a:lnRef idx="1">
+            <a:schemeClr val="accent1"/>
+          </a:lnRef>
+          <a:fillRef idx="3">
+            <a:schemeClr val="accent1"/>
+          </a:fillRef>
+          <a:effectRef idx="2">
+            <a:schemeClr val="accent1"/>
+          </a:effectRef>
+          <a:fontRef idx="minor">
+            <a:schemeClr val="lt1"/>
+          </a:fontRef>
+        </p:style>
+        <p:txBody>
+          <a:bodyPr rtlCol="0" anchor="ctr"/>
+          <a:lstStyle/>
+          <a:p>
+            <a:pPr algn="ctr"/>
           </a:p>
         </p:txBody>
       </p:sp>
@@ -3208,8 +3366,8 @@
         </p:nvSpPr>
         <p:spPr>
           <a:xfrm>
-            <a:off x="731520" y="1463040"/>
-            <a:ext cx="10698480" cy="4937760"/>
+            <a:off x="777240" y="292608"/>
+            <a:ext cx="10789920" cy="320040"/>
           </a:xfrm>
           <a:prstGeom prst="rect">
             <a:avLst/>
@@ -3222,63 +3380,410 @@
           </a:bodyPr>
           <a:lstStyle/>
           <a:p>
+            <a:pPr algn="l"/>
+            <a:r>
+              <a:rPr sz="1200" b="1">
+                <a:solidFill>
+                  <a:srgbClr val="D8432F"/>
+                </a:solidFill>
+                <a:latin typeface="Consolas"/>
+              </a:rPr>
+              <a:t>POURQUOI CE PROJET</a:t>
+            </a:r>
+          </a:p>
+        </p:txBody>
+      </p:sp>
+      <p:sp>
+        <p:nvSpPr>
+          <p:cNvPr id="4" name="TextBox 3"/>
+          <p:cNvSpPr txBox="1"/>
+          <p:nvPr/>
+        </p:nvSpPr>
+        <p:spPr>
+          <a:xfrm>
+            <a:off x="777240" y="566928"/>
+            <a:ext cx="10789920" cy="822960"/>
+          </a:xfrm>
+          <a:prstGeom prst="rect">
+            <a:avLst/>
+          </a:prstGeom>
+          <a:noFill/>
+        </p:spPr>
+        <p:txBody>
+          <a:bodyPr wrap="square">
+            <a:spAutoFit/>
+          </a:bodyPr>
+          <a:lstStyle/>
+          <a:p>
+            <a:pPr algn="l"/>
+            <a:r>
+              <a:rPr sz="3400" b="1">
+                <a:solidFill>
+                  <a:srgbClr val="16213A"/>
+                </a:solidFill>
+                <a:latin typeface="Georgia"/>
+              </a:rPr>
+              <a:t>Contexte et objectifs</a:t>
+            </a:r>
+          </a:p>
+        </p:txBody>
+      </p:sp>
+      <p:sp>
+        <p:nvSpPr>
+          <p:cNvPr id="5" name="TextBox 4"/>
+          <p:cNvSpPr txBox="1"/>
+          <p:nvPr/>
+        </p:nvSpPr>
+        <p:spPr>
+          <a:xfrm>
+            <a:off x="11475720" y="6473952"/>
+            <a:ext cx="548640" cy="320040"/>
+          </a:xfrm>
+          <a:prstGeom prst="rect">
+            <a:avLst/>
+          </a:prstGeom>
+          <a:noFill/>
+        </p:spPr>
+        <p:txBody>
+          <a:bodyPr wrap="square">
+            <a:spAutoFit/>
+          </a:bodyPr>
+          <a:lstStyle/>
+          <a:p>
+            <a:pPr algn="r"/>
+            <a:r>
+              <a:rPr sz="1100" b="0">
+                <a:solidFill>
+                  <a:srgbClr val="68707F"/>
+                </a:solidFill>
+                <a:latin typeface="Calibri"/>
+              </a:rPr>
+              <a:t>2</a:t>
+            </a:r>
+          </a:p>
+        </p:txBody>
+      </p:sp>
+      <p:sp>
+        <p:nvSpPr>
+          <p:cNvPr id="6" name="TextBox 5"/>
+          <p:cNvSpPr txBox="1"/>
+          <p:nvPr/>
+        </p:nvSpPr>
+        <p:spPr>
+          <a:xfrm>
+            <a:off x="868680" y="1691640"/>
+            <a:ext cx="6949440" cy="4754880"/>
+          </a:xfrm>
+          <a:prstGeom prst="rect">
+            <a:avLst/>
+          </a:prstGeom>
+          <a:noFill/>
+        </p:spPr>
+        <p:txBody>
+          <a:bodyPr wrap="square">
+            <a:spAutoFit/>
+          </a:bodyPr>
+          <a:lstStyle/>
+          <a:p>
             <a:pPr>
               <a:spcAft>
-                <a:spcPts val="1000"/>
+                <a:spcPts val="1200"/>
               </a:spcAft>
             </a:pPr>
             <a:r>
-              <a:rPr sz="2000">
+              <a:rPr b="1" sz="1600">
                 <a:solidFill>
                   <a:srgbClr val="16213A"/>
                 </a:solidFill>
               </a:rPr>
-              <a:t>•  Gérer des examens en ligne de bout en bout : référentiel de questions, tests, créneaux, passage et notation.</a:t>
+              <a:t>•  Problème — </a:t>
+            </a:r>
+            <a:r>
+              <a:rPr sz="1600">
+                <a:solidFill>
+                  <a:srgbClr val="16213A"/>
+                </a:solidFill>
+              </a:rPr>
+              <a:t>examens papier lourds à organiser : convocations, surveillance, correction manuelle.</a:t>
             </a:r>
           </a:p>
           <a:p>
             <a:pPr>
               <a:spcAft>
-                <a:spcPts val="1000"/>
+                <a:spcPts val="1200"/>
               </a:spcAft>
             </a:pPr>
             <a:r>
-              <a:rPr sz="2000">
+              <a:rPr b="1" sz="1600">
                 <a:solidFill>
                   <a:srgbClr val="16213A"/>
                 </a:solidFill>
               </a:rPr>
-              <a:t>•  Deux profils : Administrateur (gestion) et Candidat (inscription, examen, résultats).</a:t>
+              <a:t>•  Réponse — </a:t>
+            </a:r>
+            <a:r>
+              <a:rPr sz="1600">
+                <a:solidFill>
+                  <a:srgbClr val="16213A"/>
+                </a:solidFill>
+              </a:rPr>
+              <a:t>une plateforme web qui couvre tout le cycle : référentiel, créneaux, passage, notation.</a:t>
             </a:r>
           </a:p>
           <a:p>
             <a:pPr>
               <a:spcAft>
-                <a:spcPts val="1000"/>
+                <a:spcPts val="1200"/>
               </a:spcAft>
             </a:pPr>
             <a:r>
-              <a:rPr sz="2000">
+              <a:rPr b="1" sz="1600">
                 <a:solidFill>
                   <a:srgbClr val="16213A"/>
                 </a:solidFill>
               </a:rPr>
-              <a:t>•  Application des concepts du module : architecture en couches, UML, Spring Boot, Spring MVC, couche métier, DAO Spring Data, Spring Security.</a:t>
+              <a:t>•  Deux profils — </a:t>
+            </a:r>
+            <a:r>
+              <a:rPr sz="1600">
+                <a:solidFill>
+                  <a:srgbClr val="16213A"/>
+                </a:solidFill>
+              </a:rPr>
+              <a:t>Administrateur (gestion) et Candidat (inscription, examen, résultats).</a:t>
             </a:r>
           </a:p>
           <a:p>
             <a:pPr>
               <a:spcAft>
-                <a:spcPts val="1000"/>
+                <a:spcPts val="1200"/>
               </a:spcAft>
             </a:pPr>
             <a:r>
-              <a:rPr sz="2000">
+              <a:rPr b="1" sz="1600">
                 <a:solidFill>
                   <a:srgbClr val="16213A"/>
                 </a:solidFill>
               </a:rPr>
-              <a:t>•  CRUD complet sur 11 entités en relation + authentification JWT par rôles.</a:t>
+              <a:t>•  Cadre pédagogique — </a:t>
+            </a:r>
+            <a:r>
+              <a:rPr sz="1600">
+                <a:solidFill>
+                  <a:srgbClr val="16213A"/>
+                </a:solidFill>
+              </a:rPr>
+              <a:t>architecture en couches, UML, Spring Boot, Spring Data, Spring Security.</a:t>
+            </a:r>
+          </a:p>
+        </p:txBody>
+      </p:sp>
+      <p:sp>
+        <p:nvSpPr>
+          <p:cNvPr id="7" name="TextBox 6"/>
+          <p:cNvSpPr txBox="1"/>
+          <p:nvPr/>
+        </p:nvSpPr>
+        <p:spPr>
+          <a:xfrm>
+            <a:off x="8229600" y="1920240"/>
+            <a:ext cx="2377440" cy="914400"/>
+          </a:xfrm>
+          <a:prstGeom prst="rect">
+            <a:avLst/>
+          </a:prstGeom>
+          <a:noFill/>
+        </p:spPr>
+        <p:txBody>
+          <a:bodyPr wrap="square">
+            <a:spAutoFit/>
+          </a:bodyPr>
+          <a:lstStyle/>
+          <a:p>
+            <a:pPr algn="ctr"/>
+            <a:r>
+              <a:rPr sz="5400" b="1">
+                <a:solidFill>
+                  <a:srgbClr val="D8432F"/>
+                </a:solidFill>
+                <a:latin typeface="Georgia"/>
+              </a:rPr>
+              <a:t>11</a:t>
+            </a:r>
+          </a:p>
+        </p:txBody>
+      </p:sp>
+      <p:sp>
+        <p:nvSpPr>
+          <p:cNvPr id="8" name="TextBox 7"/>
+          <p:cNvSpPr txBox="1"/>
+          <p:nvPr/>
+        </p:nvSpPr>
+        <p:spPr>
+          <a:xfrm>
+            <a:off x="8229600" y="2788920"/>
+            <a:ext cx="2377440" cy="548640"/>
+          </a:xfrm>
+          <a:prstGeom prst="rect">
+            <a:avLst/>
+          </a:prstGeom>
+          <a:noFill/>
+        </p:spPr>
+        <p:txBody>
+          <a:bodyPr wrap="square">
+            <a:spAutoFit/>
+          </a:bodyPr>
+          <a:lstStyle/>
+          <a:p>
+            <a:pPr algn="ctr"/>
+            <a:r>
+              <a:rPr sz="1300" b="0">
+                <a:solidFill>
+                  <a:srgbClr val="68707F"/>
+                </a:solidFill>
+                <a:latin typeface="Calibri"/>
+              </a:rPr>
+              <a:t>entités JPA en relation</a:t>
+            </a:r>
+          </a:p>
+        </p:txBody>
+      </p:sp>
+      <p:sp>
+        <p:nvSpPr>
+          <p:cNvPr id="9" name="TextBox 8"/>
+          <p:cNvSpPr txBox="1"/>
+          <p:nvPr/>
+        </p:nvSpPr>
+        <p:spPr>
+          <a:xfrm>
+            <a:off x="8229600" y="3657600"/>
+            <a:ext cx="2377440" cy="914400"/>
+          </a:xfrm>
+          <a:prstGeom prst="rect">
+            <a:avLst/>
+          </a:prstGeom>
+          <a:noFill/>
+        </p:spPr>
+        <p:txBody>
+          <a:bodyPr wrap="square">
+            <a:spAutoFit/>
+          </a:bodyPr>
+          <a:lstStyle/>
+          <a:p>
+            <a:pPr algn="ctr"/>
+            <a:r>
+              <a:rPr sz="5400" b="1">
+                <a:solidFill>
+                  <a:srgbClr val="D8432F"/>
+                </a:solidFill>
+                <a:latin typeface="Georgia"/>
+              </a:rPr>
+              <a:t>9</a:t>
+            </a:r>
+          </a:p>
+        </p:txBody>
+      </p:sp>
+      <p:sp>
+        <p:nvSpPr>
+          <p:cNvPr id="10" name="TextBox 9"/>
+          <p:cNvSpPr txBox="1"/>
+          <p:nvPr/>
+        </p:nvSpPr>
+        <p:spPr>
+          <a:xfrm>
+            <a:off x="8229600" y="4526280"/>
+            <a:ext cx="2377440" cy="548640"/>
+          </a:xfrm>
+          <a:prstGeom prst="rect">
+            <a:avLst/>
+          </a:prstGeom>
+          <a:noFill/>
+        </p:spPr>
+        <p:txBody>
+          <a:bodyPr wrap="square">
+            <a:spAutoFit/>
+          </a:bodyPr>
+          <a:lstStyle/>
+          <a:p>
+            <a:pPr algn="ctr"/>
+            <a:r>
+              <a:rPr sz="1300" b="0">
+                <a:solidFill>
+                  <a:srgbClr val="68707F"/>
+                </a:solidFill>
+                <a:latin typeface="Calibri"/>
+              </a:rPr>
+              <a:t>services métier (interface + impl)</a:t>
+            </a:r>
+          </a:p>
+        </p:txBody>
+      </p:sp>
+      <p:sp>
+        <p:nvSpPr>
+          <p:cNvPr id="11" name="TextBox 10"/>
+          <p:cNvSpPr txBox="1"/>
+          <p:nvPr/>
+        </p:nvSpPr>
+        <p:spPr>
+          <a:xfrm>
+            <a:off x="8229600" y="5394960"/>
+            <a:ext cx="2377440" cy="914400"/>
+          </a:xfrm>
+          <a:prstGeom prst="rect">
+            <a:avLst/>
+          </a:prstGeom>
+          <a:noFill/>
+        </p:spPr>
+        <p:txBody>
+          <a:bodyPr wrap="square">
+            <a:spAutoFit/>
+          </a:bodyPr>
+          <a:lstStyle/>
+          <a:p>
+            <a:pPr algn="ctr"/>
+            <a:r>
+              <a:rPr sz="5400" b="1">
+                <a:solidFill>
+                  <a:srgbClr val="D8432F"/>
+                </a:solidFill>
+                <a:latin typeface="Georgia"/>
+              </a:rPr>
+              <a:t>50 %</a:t>
+            </a:r>
+          </a:p>
+        </p:txBody>
+      </p:sp>
+      <p:sp>
+        <p:nvSpPr>
+          <p:cNvPr id="12" name="TextBox 11"/>
+          <p:cNvSpPr txBox="1"/>
+          <p:nvPr/>
+        </p:nvSpPr>
+        <p:spPr>
+          <a:xfrm>
+            <a:off x="8229600" y="6263640"/>
+            <a:ext cx="2377440" cy="548640"/>
+          </a:xfrm>
+          <a:prstGeom prst="rect">
+            <a:avLst/>
+          </a:prstGeom>
+          <a:noFill/>
+        </p:spPr>
+        <p:txBody>
+          <a:bodyPr wrap="square">
+            <a:spAutoFit/>
+          </a:bodyPr>
+          <a:lstStyle/>
+          <a:p>
+            <a:pPr algn="ctr"/>
+            <a:r>
+              <a:rPr sz="1300" b="0">
+                <a:solidFill>
+                  <a:srgbClr val="68707F"/>
+                </a:solidFill>
+                <a:latin typeface="Calibri"/>
+              </a:rPr>
+              <a:t>seuil de réussite automatique</a:t>
             </a:r>
           </a:p>
         </p:txBody>
@@ -3294,6 +3799,14 @@
 <file path=ppt/slides/slide3.xml><?xml version="1.0" encoding="utf-8"?>
 <p:sld xmlns:a="http://schemas.openxmlformats.org/drawingml/2006/main" xmlns:p="http://schemas.openxmlformats.org/presentationml/2006/main" xmlns:r="http://schemas.openxmlformats.org/officeDocument/2006/relationships">
   <p:cSld>
+    <p:bg>
+      <p:bgPr>
+        <a:solidFill>
+          <a:srgbClr val="FBFAF6"/>
+        </a:solidFill>
+        <a:effectLst/>
+      </p:bgPr>
+    </p:bg>
     <p:spTree>
       <p:nvGrpSpPr>
         <p:cNvPr id="1" name=""/>
@@ -3303,14 +3816,58 @@
       <p:grpSpPr/>
       <p:sp>
         <p:nvSpPr>
-          <p:cNvPr id="2" name="TextBox 1"/>
+          <p:cNvPr id="2" name="Rectangle 1"/>
+          <p:cNvSpPr/>
+          <p:nvPr/>
+        </p:nvSpPr>
+        <p:spPr>
+          <a:xfrm>
+            <a:off x="502920" y="0"/>
+            <a:ext cx="32004" cy="6858000"/>
+          </a:xfrm>
+          <a:prstGeom prst="rect">
+            <a:avLst/>
+          </a:prstGeom>
+          <a:solidFill>
+            <a:srgbClr val="D8432F"/>
+          </a:solidFill>
+          <a:ln>
+            <a:noFill/>
+          </a:ln>
+          <a:effectLst/>
+        </p:spPr>
+        <p:style>
+          <a:lnRef idx="1">
+            <a:schemeClr val="accent1"/>
+          </a:lnRef>
+          <a:fillRef idx="3">
+            <a:schemeClr val="accent1"/>
+          </a:fillRef>
+          <a:effectRef idx="2">
+            <a:schemeClr val="accent1"/>
+          </a:effectRef>
+          <a:fontRef idx="minor">
+            <a:schemeClr val="lt1"/>
+          </a:fontRef>
+        </p:style>
+        <p:txBody>
+          <a:bodyPr rtlCol="0" anchor="ctr"/>
+          <a:lstStyle/>
+          <a:p>
+            <a:pPr algn="ctr"/>
+          </a:p>
+        </p:txBody>
+      </p:sp>
+      <p:sp>
+        <p:nvSpPr>
+          <p:cNvPr id="3" name="TextBox 2"/>
           <p:cNvSpPr txBox="1"/>
           <p:nvPr/>
         </p:nvSpPr>
         <p:spPr>
           <a:xfrm>
-            <a:off x="548640" y="320040"/>
-            <a:ext cx="11064240" cy="914400"/>
+            <a:off x="777240" y="292608"/>
+            <a:ext cx="10789920" cy="320040"/>
           </a:xfrm>
           <a:prstGeom prst="rect">
             <a:avLst/>
@@ -3318,25 +3875,97 @@
           <a:noFill/>
         </p:spPr>
         <p:txBody>
-          <a:bodyPr wrap="none">
+          <a:bodyPr wrap="square">
             <a:spAutoFit/>
           </a:bodyPr>
           <a:lstStyle/>
           <a:p>
-            <a:r>
-              <a:rPr sz="3200" b="1">
+            <a:pPr algn="l"/>
+            <a:r>
+              <a:rPr sz="1200" b="1">
+                <a:solidFill>
+                  <a:srgbClr val="D8432F"/>
+                </a:solidFill>
+                <a:latin typeface="Consolas"/>
+              </a:rPr>
+              <a:t>CONCEPTION</a:t>
+            </a:r>
+          </a:p>
+        </p:txBody>
+      </p:sp>
+      <p:sp>
+        <p:nvSpPr>
+          <p:cNvPr id="4" name="TextBox 3"/>
+          <p:cNvSpPr txBox="1"/>
+          <p:nvPr/>
+        </p:nvSpPr>
+        <p:spPr>
+          <a:xfrm>
+            <a:off x="777240" y="566928"/>
+            <a:ext cx="10789920" cy="822960"/>
+          </a:xfrm>
+          <a:prstGeom prst="rect">
+            <a:avLst/>
+          </a:prstGeom>
+          <a:noFill/>
+        </p:spPr>
+        <p:txBody>
+          <a:bodyPr wrap="square">
+            <a:spAutoFit/>
+          </a:bodyPr>
+          <a:lstStyle/>
+          <a:p>
+            <a:pPr algn="l"/>
+            <a:r>
+              <a:rPr sz="3400" b="1">
                 <a:solidFill>
                   <a:srgbClr val="16213A"/>
                 </a:solidFill>
+                <a:latin typeface="Georgia"/>
               </a:rPr>
               <a:t>Architecture technique</a:t>
+            </a:r>
+          </a:p>
+        </p:txBody>
+      </p:sp>
+      <p:sp>
+        <p:nvSpPr>
+          <p:cNvPr id="5" name="TextBox 4"/>
+          <p:cNvSpPr txBox="1"/>
+          <p:nvPr/>
+        </p:nvSpPr>
+        <p:spPr>
+          <a:xfrm>
+            <a:off x="11475720" y="6473952"/>
+            <a:ext cx="548640" cy="320040"/>
+          </a:xfrm>
+          <a:prstGeom prst="rect">
+            <a:avLst/>
+          </a:prstGeom>
+          <a:noFill/>
+        </p:spPr>
+        <p:txBody>
+          <a:bodyPr wrap="square">
+            <a:spAutoFit/>
+          </a:bodyPr>
+          <a:lstStyle/>
+          <a:p>
+            <a:pPr algn="r"/>
+            <a:r>
+              <a:rPr sz="1100" b="0">
+                <a:solidFill>
+                  <a:srgbClr val="68707F"/>
+                </a:solidFill>
+                <a:latin typeface="Calibri"/>
+              </a:rPr>
+              <a:t>3</a:t>
             </a:r>
           </a:p>
         </p:txBody>
       </p:sp>
       <p:pic>
         <p:nvPicPr>
-          <p:cNvPr id="3" name="Picture 2" descr="architecture.png"/>
+          <p:cNvPr id="6" name="Picture 5" descr="architecture.png"/>
           <p:cNvPicPr>
             <a:picLocks noChangeAspect="1"/>
           </p:cNvPicPr>
@@ -3350,8 +3979,8 @@
         </p:blipFill>
         <p:spPr>
           <a:xfrm>
-            <a:off x="2148840" y="1234440"/>
-            <a:ext cx="7493000" cy="5394960"/>
+            <a:off x="2880360" y="1481328"/>
+            <a:ext cx="7112000" cy="5120640"/>
           </a:xfrm>
           <a:prstGeom prst="rect">
             <a:avLst/>
@@ -3369,6 +3998,14 @@
 <file path=ppt/slides/slide4.xml><?xml version="1.0" encoding="utf-8"?>
 <p:sld xmlns:a="http://schemas.openxmlformats.org/drawingml/2006/main" xmlns:p="http://schemas.openxmlformats.org/presentationml/2006/main" xmlns:r="http://schemas.openxmlformats.org/officeDocument/2006/relationships">
   <p:cSld>
+    <p:bg>
+      <p:bgPr>
+        <a:solidFill>
+          <a:srgbClr val="FBFAF6"/>
+        </a:solidFill>
+        <a:effectLst/>
+      </p:bgPr>
+    </p:bg>
     <p:spTree>
       <p:nvGrpSpPr>
         <p:cNvPr id="1" name=""/>
@@ -3378,14 +4015,58 @@
       <p:grpSpPr/>
       <p:sp>
         <p:nvSpPr>
-          <p:cNvPr id="2" name="TextBox 1"/>
+          <p:cNvPr id="2" name="Rectangle 1"/>
+          <p:cNvSpPr/>
+          <p:nvPr/>
+        </p:nvSpPr>
+        <p:spPr>
+          <a:xfrm>
+            <a:off x="502920" y="0"/>
+            <a:ext cx="32004" cy="6858000"/>
+          </a:xfrm>
+          <a:prstGeom prst="rect">
+            <a:avLst/>
+          </a:prstGeom>
+          <a:solidFill>
+            <a:srgbClr val="D8432F"/>
+          </a:solidFill>
+          <a:ln>
+            <a:noFill/>
+          </a:ln>
+          <a:effectLst/>
+        </p:spPr>
+        <p:style>
+          <a:lnRef idx="1">
+            <a:schemeClr val="accent1"/>
+          </a:lnRef>
+          <a:fillRef idx="3">
+            <a:schemeClr val="accent1"/>
+          </a:fillRef>
+          <a:effectRef idx="2">
+            <a:schemeClr val="accent1"/>
+          </a:effectRef>
+          <a:fontRef idx="minor">
+            <a:schemeClr val="lt1"/>
+          </a:fontRef>
+        </p:style>
+        <p:txBody>
+          <a:bodyPr rtlCol="0" anchor="ctr"/>
+          <a:lstStyle/>
+          <a:p>
+            <a:pPr algn="ctr"/>
+          </a:p>
+        </p:txBody>
+      </p:sp>
+      <p:sp>
+        <p:nvSpPr>
+          <p:cNvPr id="3" name="TextBox 2"/>
           <p:cNvSpPr txBox="1"/>
           <p:nvPr/>
         </p:nvSpPr>
         <p:spPr>
           <a:xfrm>
-            <a:off x="548640" y="320040"/>
-            <a:ext cx="11064240" cy="914400"/>
+            <a:off x="777240" y="292608"/>
+            <a:ext cx="10789920" cy="320040"/>
           </a:xfrm>
           <a:prstGeom prst="rect">
             <a:avLst/>
@@ -3393,25 +4074,97 @@
           <a:noFill/>
         </p:spPr>
         <p:txBody>
-          <a:bodyPr wrap="none">
+          <a:bodyPr wrap="square">
             <a:spAutoFit/>
           </a:bodyPr>
           <a:lstStyle/>
           <a:p>
-            <a:r>
-              <a:rPr sz="3200" b="1">
+            <a:pPr algn="l"/>
+            <a:r>
+              <a:rPr sz="1200" b="1">
+                <a:solidFill>
+                  <a:srgbClr val="D8432F"/>
+                </a:solidFill>
+                <a:latin typeface="Consolas"/>
+              </a:rPr>
+              <a:t>CONCEPTION</a:t>
+            </a:r>
+          </a:p>
+        </p:txBody>
+      </p:sp>
+      <p:sp>
+        <p:nvSpPr>
+          <p:cNvPr id="4" name="TextBox 3"/>
+          <p:cNvSpPr txBox="1"/>
+          <p:nvPr/>
+        </p:nvSpPr>
+        <p:spPr>
+          <a:xfrm>
+            <a:off x="777240" y="566928"/>
+            <a:ext cx="10789920" cy="822960"/>
+          </a:xfrm>
+          <a:prstGeom prst="rect">
+            <a:avLst/>
+          </a:prstGeom>
+          <a:noFill/>
+        </p:spPr>
+        <p:txBody>
+          <a:bodyPr wrap="square">
+            <a:spAutoFit/>
+          </a:bodyPr>
+          <a:lstStyle/>
+          <a:p>
+            <a:pPr algn="l"/>
+            <a:r>
+              <a:rPr sz="3400" b="1">
                 <a:solidFill>
                   <a:srgbClr val="16213A"/>
                 </a:solidFill>
-              </a:rPr>
-              <a:t>Diagramme de classes UML — Entités du domaine</a:t>
+                <a:latin typeface="Georgia"/>
+              </a:rPr>
+              <a:t>Diagramme de classes — entités du domaine</a:t>
+            </a:r>
+          </a:p>
+        </p:txBody>
+      </p:sp>
+      <p:sp>
+        <p:nvSpPr>
+          <p:cNvPr id="5" name="TextBox 4"/>
+          <p:cNvSpPr txBox="1"/>
+          <p:nvPr/>
+        </p:nvSpPr>
+        <p:spPr>
+          <a:xfrm>
+            <a:off x="11475720" y="6473952"/>
+            <a:ext cx="548640" cy="320040"/>
+          </a:xfrm>
+          <a:prstGeom prst="rect">
+            <a:avLst/>
+          </a:prstGeom>
+          <a:noFill/>
+        </p:spPr>
+        <p:txBody>
+          <a:bodyPr wrap="square">
+            <a:spAutoFit/>
+          </a:bodyPr>
+          <a:lstStyle/>
+          <a:p>
+            <a:pPr algn="r"/>
+            <a:r>
+              <a:rPr sz="1100" b="0">
+                <a:solidFill>
+                  <a:srgbClr val="68707F"/>
+                </a:solidFill>
+                <a:latin typeface="Calibri"/>
+              </a:rPr>
+              <a:t>4</a:t>
             </a:r>
           </a:p>
         </p:txBody>
       </p:sp>
       <p:pic>
         <p:nvPicPr>
-          <p:cNvPr id="3" name="Picture 2" descr="entites.png"/>
+          <p:cNvPr id="6" name="Picture 5" descr="entites.png"/>
           <p:cNvPicPr>
             <a:picLocks noChangeAspect="1"/>
           </p:cNvPicPr>
@@ -3425,8 +4178,8 @@
         </p:blipFill>
         <p:spPr>
           <a:xfrm>
-            <a:off x="2606040" y="1280160"/>
-            <a:ext cx="6987896" cy="5349240"/>
+            <a:off x="3063240" y="1481328"/>
+            <a:ext cx="6629542" cy="5074920"/>
           </a:xfrm>
           <a:prstGeom prst="rect">
             <a:avLst/>
@@ -3444,6 +4197,14 @@
 <file path=ppt/slides/slide5.xml><?xml version="1.0" encoding="utf-8"?>
 <p:sld xmlns:a="http://schemas.openxmlformats.org/drawingml/2006/main" xmlns:p="http://schemas.openxmlformats.org/presentationml/2006/main" xmlns:r="http://schemas.openxmlformats.org/officeDocument/2006/relationships">
   <p:cSld>
+    <p:bg>
+      <p:bgPr>
+        <a:solidFill>
+          <a:srgbClr val="FBFAF6"/>
+        </a:solidFill>
+        <a:effectLst/>
+      </p:bgPr>
+    </p:bg>
     <p:spTree>
       <p:nvGrpSpPr>
         <p:cNvPr id="1" name=""/>
@@ -3453,34 +4214,45 @@
       <p:grpSpPr/>
       <p:sp>
         <p:nvSpPr>
-          <p:cNvPr id="2" name="TextBox 1"/>
-          <p:cNvSpPr txBox="1"/>
-          <p:nvPr/>
-        </p:nvSpPr>
-        <p:spPr>
-          <a:xfrm>
-            <a:off x="548640" y="320040"/>
-            <a:ext cx="11064240" cy="914400"/>
-          </a:xfrm>
-          <a:prstGeom prst="rect">
-            <a:avLst/>
-          </a:prstGeom>
-          <a:noFill/>
-        </p:spPr>
-        <p:txBody>
-          <a:bodyPr wrap="none">
-            <a:spAutoFit/>
-          </a:bodyPr>
-          <a:lstStyle/>
-          <a:p>
-            <a:r>
-              <a:rPr sz="3200" b="1">
-                <a:solidFill>
-                  <a:srgbClr val="16213A"/>
-                </a:solidFill>
-              </a:rPr>
-              <a:t>Sécurisation — Spring Security + JWT</a:t>
-            </a:r>
+          <p:cNvPr id="2" name="Rectangle 1"/>
+          <p:cNvSpPr/>
+          <p:nvPr/>
+        </p:nvSpPr>
+        <p:spPr>
+          <a:xfrm>
+            <a:off x="502920" y="0"/>
+            <a:ext cx="32004" cy="6858000"/>
+          </a:xfrm>
+          <a:prstGeom prst="rect">
+            <a:avLst/>
+          </a:prstGeom>
+          <a:solidFill>
+            <a:srgbClr val="D8432F"/>
+          </a:solidFill>
+          <a:ln>
+            <a:noFill/>
+          </a:ln>
+          <a:effectLst/>
+        </p:spPr>
+        <p:style>
+          <a:lnRef idx="1">
+            <a:schemeClr val="accent1"/>
+          </a:lnRef>
+          <a:fillRef idx="3">
+            <a:schemeClr val="accent1"/>
+          </a:fillRef>
+          <a:effectRef idx="2">
+            <a:schemeClr val="accent1"/>
+          </a:effectRef>
+          <a:fontRef idx="minor">
+            <a:schemeClr val="lt1"/>
+          </a:fontRef>
+        </p:style>
+        <p:txBody>
+          <a:bodyPr rtlCol="0" anchor="ctr"/>
+          <a:lstStyle/>
+          <a:p>
+            <a:pPr algn="ctr"/>
           </a:p>
         </p:txBody>
       </p:sp>
@@ -3492,8 +4264,8 @@
         </p:nvSpPr>
         <p:spPr>
           <a:xfrm>
-            <a:off x="731520" y="1463040"/>
-            <a:ext cx="10698480" cy="4937760"/>
+            <a:off x="777240" y="292608"/>
+            <a:ext cx="10789920" cy="320040"/>
           </a:xfrm>
           <a:prstGeom prst="rect">
             <a:avLst/>
@@ -3506,78 +4278,608 @@
           </a:bodyPr>
           <a:lstStyle/>
           <a:p>
-            <a:pPr>
-              <a:spcAft>
-                <a:spcPts val="1000"/>
-              </a:spcAft>
-            </a:pPr>
-            <a:r>
-              <a:rPr sz="2000">
+            <a:pPr algn="l"/>
+            <a:r>
+              <a:rPr sz="1200" b="1">
+                <a:solidFill>
+                  <a:srgbClr val="D8432F"/>
+                </a:solidFill>
+                <a:latin typeface="Consolas"/>
+              </a:rPr>
+              <a:t>RÉALISATION</a:t>
+            </a:r>
+          </a:p>
+        </p:txBody>
+      </p:sp>
+      <p:sp>
+        <p:nvSpPr>
+          <p:cNvPr id="4" name="TextBox 3"/>
+          <p:cNvSpPr txBox="1"/>
+          <p:nvPr/>
+        </p:nvSpPr>
+        <p:spPr>
+          <a:xfrm>
+            <a:off x="777240" y="566928"/>
+            <a:ext cx="10789920" cy="822960"/>
+          </a:xfrm>
+          <a:prstGeom prst="rect">
+            <a:avLst/>
+          </a:prstGeom>
+          <a:noFill/>
+        </p:spPr>
+        <p:txBody>
+          <a:bodyPr wrap="square">
+            <a:spAutoFit/>
+          </a:bodyPr>
+          <a:lstStyle/>
+          <a:p>
+            <a:pPr algn="l"/>
+            <a:r>
+              <a:rPr sz="3400" b="1">
                 <a:solidFill>
                   <a:srgbClr val="16213A"/>
                 </a:solidFill>
-              </a:rPr>
-              <a:t>•  Authentification stateless : login → JWT signé HS256 (email, rôle, id).</a:t>
-            </a:r>
-          </a:p>
-          <a:p>
-            <a:pPr>
-              <a:spcAft>
-                <a:spcPts val="1000"/>
-              </a:spcAft>
-            </a:pPr>
-            <a:r>
-              <a:rPr sz="2000">
+                <a:latin typeface="Georgia"/>
+              </a:rPr>
+              <a:t>Sécurisation — Spring Security + JWT</a:t>
+            </a:r>
+          </a:p>
+        </p:txBody>
+      </p:sp>
+      <p:sp>
+        <p:nvSpPr>
+          <p:cNvPr id="5" name="TextBox 4"/>
+          <p:cNvSpPr txBox="1"/>
+          <p:nvPr/>
+        </p:nvSpPr>
+        <p:spPr>
+          <a:xfrm>
+            <a:off x="11475720" y="6473952"/>
+            <a:ext cx="548640" cy="320040"/>
+          </a:xfrm>
+          <a:prstGeom prst="rect">
+            <a:avLst/>
+          </a:prstGeom>
+          <a:noFill/>
+        </p:spPr>
+        <p:txBody>
+          <a:bodyPr wrap="square">
+            <a:spAutoFit/>
+          </a:bodyPr>
+          <a:lstStyle/>
+          <a:p>
+            <a:pPr algn="r"/>
+            <a:r>
+              <a:rPr sz="1100" b="0">
+                <a:solidFill>
+                  <a:srgbClr val="68707F"/>
+                </a:solidFill>
+                <a:latin typeface="Calibri"/>
+              </a:rPr>
+              <a:t>5</a:t>
+            </a:r>
+          </a:p>
+        </p:txBody>
+      </p:sp>
+      <p:sp>
+        <p:nvSpPr>
+          <p:cNvPr id="6" name="Oval 5"/>
+          <p:cNvSpPr/>
+          <p:nvPr/>
+        </p:nvSpPr>
+        <p:spPr>
+          <a:xfrm>
+            <a:off x="960120" y="1783080"/>
+            <a:ext cx="502920" cy="502920"/>
+          </a:xfrm>
+          <a:prstGeom prst="ellipse">
+            <a:avLst/>
+          </a:prstGeom>
+          <a:solidFill>
+            <a:srgbClr val="D8432F"/>
+          </a:solidFill>
+          <a:ln>
+            <a:noFill/>
+          </a:ln>
+          <a:effectLst/>
+        </p:spPr>
+        <p:style>
+          <a:lnRef idx="1">
+            <a:schemeClr val="accent1"/>
+          </a:lnRef>
+          <a:fillRef idx="3">
+            <a:schemeClr val="accent1"/>
+          </a:fillRef>
+          <a:effectRef idx="2">
+            <a:schemeClr val="accent1"/>
+          </a:effectRef>
+          <a:fontRef idx="minor">
+            <a:schemeClr val="lt1"/>
+          </a:fontRef>
+        </p:style>
+        <p:txBody>
+          <a:bodyPr rtlCol="0" anchor="ctr"/>
+          <a:lstStyle/>
+          <a:p>
+            <a:pPr algn="ctr"/>
+            <a:r>
+              <a:rPr sz="2000" b="1">
+                <a:solidFill>
+                  <a:srgbClr val="FFFFFF"/>
+                </a:solidFill>
+              </a:rPr>
+              <a:t>1</a:t>
+            </a:r>
+          </a:p>
+        </p:txBody>
+      </p:sp>
+      <p:sp>
+        <p:nvSpPr>
+          <p:cNvPr id="7" name="TextBox 6"/>
+          <p:cNvSpPr txBox="1"/>
+          <p:nvPr/>
+        </p:nvSpPr>
+        <p:spPr>
+          <a:xfrm>
+            <a:off x="1691640" y="1755648"/>
+            <a:ext cx="2743200" cy="457200"/>
+          </a:xfrm>
+          <a:prstGeom prst="rect">
+            <a:avLst/>
+          </a:prstGeom>
+          <a:noFill/>
+        </p:spPr>
+        <p:txBody>
+          <a:bodyPr wrap="square">
+            <a:spAutoFit/>
+          </a:bodyPr>
+          <a:lstStyle/>
+          <a:p>
+            <a:pPr algn="l"/>
+            <a:r>
+              <a:rPr sz="1900" b="1">
                 <a:solidFill>
                   <a:srgbClr val="16213A"/>
                 </a:solidFill>
-              </a:rPr>
-              <a:t>•  Mots de passe hachés avec BCrypt.</a:t>
-            </a:r>
-          </a:p>
-          <a:p>
-            <a:pPr>
-              <a:spcAft>
-                <a:spcPts val="1000"/>
-              </a:spcAft>
-            </a:pPr>
-            <a:r>
-              <a:rPr sz="2000">
+                <a:latin typeface="Georgia"/>
+              </a:rPr>
+              <a:t>Connexion</a:t>
+            </a:r>
+          </a:p>
+        </p:txBody>
+      </p:sp>
+      <p:sp>
+        <p:nvSpPr>
+          <p:cNvPr id="8" name="TextBox 7"/>
+          <p:cNvSpPr txBox="1"/>
+          <p:nvPr/>
+        </p:nvSpPr>
+        <p:spPr>
+          <a:xfrm>
+            <a:off x="4572000" y="1801368"/>
+            <a:ext cx="6949440" cy="548640"/>
+          </a:xfrm>
+          <a:prstGeom prst="rect">
+            <a:avLst/>
+          </a:prstGeom>
+          <a:noFill/>
+        </p:spPr>
+        <p:txBody>
+          <a:bodyPr wrap="square">
+            <a:spAutoFit/>
+          </a:bodyPr>
+          <a:lstStyle/>
+          <a:p>
+            <a:pPr algn="l"/>
+            <a:r>
+              <a:rPr sz="1500" b="0">
                 <a:solidFill>
                   <a:srgbClr val="16213A"/>
                 </a:solidFill>
-              </a:rPr>
-              <a:t>•  JwtAuthFilter valide le jeton à chaque requête (Authorization: Bearer).</a:t>
-            </a:r>
-          </a:p>
-          <a:p>
-            <a:pPr>
-              <a:spcAft>
-                <a:spcPts val="1000"/>
-              </a:spcAft>
-            </a:pPr>
-            <a:r>
-              <a:rPr sz="2000">
+                <a:latin typeface="Calibri"/>
+              </a:rPr>
+              <a:t>login / mot de passe — hachage BCrypt vérifié en base</a:t>
+            </a:r>
+          </a:p>
+        </p:txBody>
+      </p:sp>
+      <p:sp>
+        <p:nvSpPr>
+          <p:cNvPr id="9" name="Oval 8"/>
+          <p:cNvSpPr/>
+          <p:nvPr/>
+        </p:nvSpPr>
+        <p:spPr>
+          <a:xfrm>
+            <a:off x="960120" y="2926080"/>
+            <a:ext cx="502920" cy="502920"/>
+          </a:xfrm>
+          <a:prstGeom prst="ellipse">
+            <a:avLst/>
+          </a:prstGeom>
+          <a:solidFill>
+            <a:srgbClr val="D8432F"/>
+          </a:solidFill>
+          <a:ln>
+            <a:noFill/>
+          </a:ln>
+          <a:effectLst/>
+        </p:spPr>
+        <p:style>
+          <a:lnRef idx="1">
+            <a:schemeClr val="accent1"/>
+          </a:lnRef>
+          <a:fillRef idx="3">
+            <a:schemeClr val="accent1"/>
+          </a:fillRef>
+          <a:effectRef idx="2">
+            <a:schemeClr val="accent1"/>
+          </a:effectRef>
+          <a:fontRef idx="minor">
+            <a:schemeClr val="lt1"/>
+          </a:fontRef>
+        </p:style>
+        <p:txBody>
+          <a:bodyPr rtlCol="0" anchor="ctr"/>
+          <a:lstStyle/>
+          <a:p>
+            <a:pPr algn="ctr"/>
+            <a:r>
+              <a:rPr sz="2000" b="1">
+                <a:solidFill>
+                  <a:srgbClr val="FFFFFF"/>
+                </a:solidFill>
+              </a:rPr>
+              <a:t>2</a:t>
+            </a:r>
+          </a:p>
+        </p:txBody>
+      </p:sp>
+      <p:sp>
+        <p:nvSpPr>
+          <p:cNvPr id="10" name="TextBox 9"/>
+          <p:cNvSpPr txBox="1"/>
+          <p:nvPr/>
+        </p:nvSpPr>
+        <p:spPr>
+          <a:xfrm>
+            <a:off x="1691640" y="2898648"/>
+            <a:ext cx="2743200" cy="457200"/>
+          </a:xfrm>
+          <a:prstGeom prst="rect">
+            <a:avLst/>
+          </a:prstGeom>
+          <a:noFill/>
+        </p:spPr>
+        <p:txBody>
+          <a:bodyPr wrap="square">
+            <a:spAutoFit/>
+          </a:bodyPr>
+          <a:lstStyle/>
+          <a:p>
+            <a:pPr algn="l"/>
+            <a:r>
+              <a:rPr sz="1900" b="1">
                 <a:solidFill>
                   <a:srgbClr val="16213A"/>
                 </a:solidFill>
-              </a:rPr>
-              <a:t>•  Autorisations par rôle : /api/admin/** → ADMIN, /api/candidate/** → CANDIDATE, /api/auth/** public.</a:t>
-            </a:r>
-          </a:p>
-          <a:p>
-            <a:pPr>
-              <a:spcAft>
-                <a:spcPts val="1000"/>
-              </a:spcAft>
-            </a:pPr>
-            <a:r>
-              <a:rPr sz="2000">
+                <a:latin typeface="Georgia"/>
+              </a:rPr>
+              <a:t>Jeton JWT</a:t>
+            </a:r>
+          </a:p>
+        </p:txBody>
+      </p:sp>
+      <p:sp>
+        <p:nvSpPr>
+          <p:cNvPr id="11" name="TextBox 10"/>
+          <p:cNvSpPr txBox="1"/>
+          <p:nvPr/>
+        </p:nvSpPr>
+        <p:spPr>
+          <a:xfrm>
+            <a:off x="4572000" y="2944368"/>
+            <a:ext cx="6949440" cy="548640"/>
+          </a:xfrm>
+          <a:prstGeom prst="rect">
+            <a:avLst/>
+          </a:prstGeom>
+          <a:noFill/>
+        </p:spPr>
+        <p:txBody>
+          <a:bodyPr wrap="square">
+            <a:spAutoFit/>
+          </a:bodyPr>
+          <a:lstStyle/>
+          <a:p>
+            <a:pPr algn="l"/>
+            <a:r>
+              <a:rPr sz="1500" b="0">
                 <a:solidFill>
                   <a:srgbClr val="16213A"/>
                 </a:solidFill>
-              </a:rPr>
-              <a:t>•  Un candidat ne peut accéder qu'à ses propres sessions et résultats.</a:t>
+                <a:latin typeface="Calibri"/>
+              </a:rPr>
+              <a:t>signé HS256, contient email, rôle et identifiant</a:t>
+            </a:r>
+          </a:p>
+        </p:txBody>
+      </p:sp>
+      <p:sp>
+        <p:nvSpPr>
+          <p:cNvPr id="12" name="Oval 11"/>
+          <p:cNvSpPr/>
+          <p:nvPr/>
+        </p:nvSpPr>
+        <p:spPr>
+          <a:xfrm>
+            <a:off x="960120" y="4069080"/>
+            <a:ext cx="502920" cy="502920"/>
+          </a:xfrm>
+          <a:prstGeom prst="ellipse">
+            <a:avLst/>
+          </a:prstGeom>
+          <a:solidFill>
+            <a:srgbClr val="D8432F"/>
+          </a:solidFill>
+          <a:ln>
+            <a:noFill/>
+          </a:ln>
+          <a:effectLst/>
+        </p:spPr>
+        <p:style>
+          <a:lnRef idx="1">
+            <a:schemeClr val="accent1"/>
+          </a:lnRef>
+          <a:fillRef idx="3">
+            <a:schemeClr val="accent1"/>
+          </a:fillRef>
+          <a:effectRef idx="2">
+            <a:schemeClr val="accent1"/>
+          </a:effectRef>
+          <a:fontRef idx="minor">
+            <a:schemeClr val="lt1"/>
+          </a:fontRef>
+        </p:style>
+        <p:txBody>
+          <a:bodyPr rtlCol="0" anchor="ctr"/>
+          <a:lstStyle/>
+          <a:p>
+            <a:pPr algn="ctr"/>
+            <a:r>
+              <a:rPr sz="2000" b="1">
+                <a:solidFill>
+                  <a:srgbClr val="FFFFFF"/>
+                </a:solidFill>
+              </a:rPr>
+              <a:t>3</a:t>
+            </a:r>
+          </a:p>
+        </p:txBody>
+      </p:sp>
+      <p:sp>
+        <p:nvSpPr>
+          <p:cNvPr id="13" name="TextBox 12"/>
+          <p:cNvSpPr txBox="1"/>
+          <p:nvPr/>
+        </p:nvSpPr>
+        <p:spPr>
+          <a:xfrm>
+            <a:off x="1691640" y="4041648"/>
+            <a:ext cx="2743200" cy="457200"/>
+          </a:xfrm>
+          <a:prstGeom prst="rect">
+            <a:avLst/>
+          </a:prstGeom>
+          <a:noFill/>
+        </p:spPr>
+        <p:txBody>
+          <a:bodyPr wrap="square">
+            <a:spAutoFit/>
+          </a:bodyPr>
+          <a:lstStyle/>
+          <a:p>
+            <a:pPr algn="l"/>
+            <a:r>
+              <a:rPr sz="1900" b="1">
+                <a:solidFill>
+                  <a:srgbClr val="16213A"/>
+                </a:solidFill>
+                <a:latin typeface="Georgia"/>
+              </a:rPr>
+              <a:t>Filtre</a:t>
+            </a:r>
+          </a:p>
+        </p:txBody>
+      </p:sp>
+      <p:sp>
+        <p:nvSpPr>
+          <p:cNvPr id="14" name="TextBox 13"/>
+          <p:cNvSpPr txBox="1"/>
+          <p:nvPr/>
+        </p:nvSpPr>
+        <p:spPr>
+          <a:xfrm>
+            <a:off x="4572000" y="4087368"/>
+            <a:ext cx="6949440" cy="548640"/>
+          </a:xfrm>
+          <a:prstGeom prst="rect">
+            <a:avLst/>
+          </a:prstGeom>
+          <a:noFill/>
+        </p:spPr>
+        <p:txBody>
+          <a:bodyPr wrap="square">
+            <a:spAutoFit/>
+          </a:bodyPr>
+          <a:lstStyle/>
+          <a:p>
+            <a:pPr algn="l"/>
+            <a:r>
+              <a:rPr sz="1500" b="0">
+                <a:solidFill>
+                  <a:srgbClr val="16213A"/>
+                </a:solidFill>
+                <a:latin typeface="Calibri"/>
+              </a:rPr>
+              <a:t>JwtAuthFilter valide « Authorization: Bearer » à chaque requête</a:t>
+            </a:r>
+          </a:p>
+        </p:txBody>
+      </p:sp>
+      <p:sp>
+        <p:nvSpPr>
+          <p:cNvPr id="15" name="Oval 14"/>
+          <p:cNvSpPr/>
+          <p:nvPr/>
+        </p:nvSpPr>
+        <p:spPr>
+          <a:xfrm>
+            <a:off x="960120" y="5212080"/>
+            <a:ext cx="502920" cy="502920"/>
+          </a:xfrm>
+          <a:prstGeom prst="ellipse">
+            <a:avLst/>
+          </a:prstGeom>
+          <a:solidFill>
+            <a:srgbClr val="D8432F"/>
+          </a:solidFill>
+          <a:ln>
+            <a:noFill/>
+          </a:ln>
+          <a:effectLst/>
+        </p:spPr>
+        <p:style>
+          <a:lnRef idx="1">
+            <a:schemeClr val="accent1"/>
+          </a:lnRef>
+          <a:fillRef idx="3">
+            <a:schemeClr val="accent1"/>
+          </a:fillRef>
+          <a:effectRef idx="2">
+            <a:schemeClr val="accent1"/>
+          </a:effectRef>
+          <a:fontRef idx="minor">
+            <a:schemeClr val="lt1"/>
+          </a:fontRef>
+        </p:style>
+        <p:txBody>
+          <a:bodyPr rtlCol="0" anchor="ctr"/>
+          <a:lstStyle/>
+          <a:p>
+            <a:pPr algn="ctr"/>
+            <a:r>
+              <a:rPr sz="2000" b="1">
+                <a:solidFill>
+                  <a:srgbClr val="FFFFFF"/>
+                </a:solidFill>
+              </a:rPr>
+              <a:t>4</a:t>
+            </a:r>
+          </a:p>
+        </p:txBody>
+      </p:sp>
+      <p:sp>
+        <p:nvSpPr>
+          <p:cNvPr id="16" name="TextBox 15"/>
+          <p:cNvSpPr txBox="1"/>
+          <p:nvPr/>
+        </p:nvSpPr>
+        <p:spPr>
+          <a:xfrm>
+            <a:off x="1691640" y="5184648"/>
+            <a:ext cx="2743200" cy="457200"/>
+          </a:xfrm>
+          <a:prstGeom prst="rect">
+            <a:avLst/>
+          </a:prstGeom>
+          <a:noFill/>
+        </p:spPr>
+        <p:txBody>
+          <a:bodyPr wrap="square">
+            <a:spAutoFit/>
+          </a:bodyPr>
+          <a:lstStyle/>
+          <a:p>
+            <a:pPr algn="l"/>
+            <a:r>
+              <a:rPr sz="1900" b="1">
+                <a:solidFill>
+                  <a:srgbClr val="16213A"/>
+                </a:solidFill>
+                <a:latin typeface="Georgia"/>
+              </a:rPr>
+              <a:t>Autorisations</a:t>
+            </a:r>
+          </a:p>
+        </p:txBody>
+      </p:sp>
+      <p:sp>
+        <p:nvSpPr>
+          <p:cNvPr id="17" name="TextBox 16"/>
+          <p:cNvSpPr txBox="1"/>
+          <p:nvPr/>
+        </p:nvSpPr>
+        <p:spPr>
+          <a:xfrm>
+            <a:off x="4572000" y="5230368"/>
+            <a:ext cx="6949440" cy="548640"/>
+          </a:xfrm>
+          <a:prstGeom prst="rect">
+            <a:avLst/>
+          </a:prstGeom>
+          <a:noFill/>
+        </p:spPr>
+        <p:txBody>
+          <a:bodyPr wrap="square">
+            <a:spAutoFit/>
+          </a:bodyPr>
+          <a:lstStyle/>
+          <a:p>
+            <a:pPr algn="l"/>
+            <a:r>
+              <a:rPr sz="1500" b="0">
+                <a:solidFill>
+                  <a:srgbClr val="16213A"/>
+                </a:solidFill>
+                <a:latin typeface="Calibri"/>
+              </a:rPr>
+              <a:t>/api/admin/** → ADMIN · /api/candidate/** → CANDIDATE · /api/auth/** public</a:t>
+            </a:r>
+          </a:p>
+        </p:txBody>
+      </p:sp>
+      <p:sp>
+        <p:nvSpPr>
+          <p:cNvPr id="18" name="TextBox 17"/>
+          <p:cNvSpPr txBox="1"/>
+          <p:nvPr/>
+        </p:nvSpPr>
+        <p:spPr>
+          <a:xfrm>
+            <a:off x="1691640" y="6400800"/>
+            <a:ext cx="9875520" cy="457200"/>
+          </a:xfrm>
+          <a:prstGeom prst="rect">
+            <a:avLst/>
+          </a:prstGeom>
+          <a:noFill/>
+        </p:spPr>
+        <p:txBody>
+          <a:bodyPr wrap="square">
+            <a:spAutoFit/>
+          </a:bodyPr>
+          <a:lstStyle/>
+          <a:p>
+            <a:pPr algn="l"/>
+            <a:r>
+              <a:rPr sz="1400" b="0">
+                <a:solidFill>
+                  <a:srgbClr val="68707F"/>
+                </a:solidFill>
+                <a:latin typeface="Calibri"/>
+              </a:rPr>
+              <a:t>Un candidat ne peut démarrer, soumettre ou consulter que ses propres sessions.</a:t>
             </a:r>
           </a:p>
         </p:txBody>
@@ -3593,6 +4895,14 @@
 <file path=ppt/slides/slide6.xml><?xml version="1.0" encoding="utf-8"?>
 <p:sld xmlns:a="http://schemas.openxmlformats.org/drawingml/2006/main" xmlns:p="http://schemas.openxmlformats.org/presentationml/2006/main" xmlns:r="http://schemas.openxmlformats.org/officeDocument/2006/relationships">
   <p:cSld>
+    <p:bg>
+      <p:bgPr>
+        <a:solidFill>
+          <a:srgbClr val="FBFAF6"/>
+        </a:solidFill>
+        <a:effectLst/>
+      </p:bgPr>
+    </p:bg>
     <p:spTree>
       <p:nvGrpSpPr>
         <p:cNvPr id="1" name=""/>
@@ -3602,14 +4912,58 @@
       <p:grpSpPr/>
       <p:sp>
         <p:nvSpPr>
-          <p:cNvPr id="2" name="TextBox 1"/>
+          <p:cNvPr id="2" name="Rectangle 1"/>
+          <p:cNvSpPr/>
+          <p:nvPr/>
+        </p:nvSpPr>
+        <p:spPr>
+          <a:xfrm>
+            <a:off x="502920" y="0"/>
+            <a:ext cx="32004" cy="6858000"/>
+          </a:xfrm>
+          <a:prstGeom prst="rect">
+            <a:avLst/>
+          </a:prstGeom>
+          <a:solidFill>
+            <a:srgbClr val="D8432F"/>
+          </a:solidFill>
+          <a:ln>
+            <a:noFill/>
+          </a:ln>
+          <a:effectLst/>
+        </p:spPr>
+        <p:style>
+          <a:lnRef idx="1">
+            <a:schemeClr val="accent1"/>
+          </a:lnRef>
+          <a:fillRef idx="3">
+            <a:schemeClr val="accent1"/>
+          </a:fillRef>
+          <a:effectRef idx="2">
+            <a:schemeClr val="accent1"/>
+          </a:effectRef>
+          <a:fontRef idx="minor">
+            <a:schemeClr val="lt1"/>
+          </a:fontRef>
+        </p:style>
+        <p:txBody>
+          <a:bodyPr rtlCol="0" anchor="ctr"/>
+          <a:lstStyle/>
+          <a:p>
+            <a:pPr algn="ctr"/>
+          </a:p>
+        </p:txBody>
+      </p:sp>
+      <p:sp>
+        <p:nvSpPr>
+          <p:cNvPr id="3" name="TextBox 2"/>
           <p:cNvSpPr txBox="1"/>
           <p:nvPr/>
         </p:nvSpPr>
         <p:spPr>
           <a:xfrm>
-            <a:off x="548640" y="320040"/>
-            <a:ext cx="11064240" cy="914400"/>
+            <a:off x="777240" y="292608"/>
+            <a:ext cx="10789920" cy="320040"/>
           </a:xfrm>
           <a:prstGeom prst="rect">
             <a:avLst/>
@@ -3617,25 +4971,97 @@
           <a:noFill/>
         </p:spPr>
         <p:txBody>
-          <a:bodyPr wrap="none">
+          <a:bodyPr wrap="square">
             <a:spAutoFit/>
           </a:bodyPr>
           <a:lstStyle/>
           <a:p>
-            <a:r>
-              <a:rPr sz="3200" b="1">
+            <a:pPr algn="l"/>
+            <a:r>
+              <a:rPr sz="1200" b="1">
+                <a:solidFill>
+                  <a:srgbClr val="D8432F"/>
+                </a:solidFill>
+                <a:latin typeface="Consolas"/>
+              </a:rPr>
+              <a:t>DÉMONSTRATION</a:t>
+            </a:r>
+          </a:p>
+        </p:txBody>
+      </p:sp>
+      <p:sp>
+        <p:nvSpPr>
+          <p:cNvPr id="4" name="TextBox 3"/>
+          <p:cNvSpPr txBox="1"/>
+          <p:nvPr/>
+        </p:nvSpPr>
+        <p:spPr>
+          <a:xfrm>
+            <a:off x="777240" y="566928"/>
+            <a:ext cx="10789920" cy="822960"/>
+          </a:xfrm>
+          <a:prstGeom prst="rect">
+            <a:avLst/>
+          </a:prstGeom>
+          <a:noFill/>
+        </p:spPr>
+        <p:txBody>
+          <a:bodyPr wrap="square">
+            <a:spAutoFit/>
+          </a:bodyPr>
+          <a:lstStyle/>
+          <a:p>
+            <a:pPr algn="l"/>
+            <a:r>
+              <a:rPr sz="3400" b="1">
                 <a:solidFill>
                   <a:srgbClr val="16213A"/>
                 </a:solidFill>
-              </a:rPr>
-              <a:t>Démonstration — Accueil et connexion</a:t>
+                <a:latin typeface="Georgia"/>
+              </a:rPr>
+              <a:t>Accueil et connexion</a:t>
+            </a:r>
+          </a:p>
+        </p:txBody>
+      </p:sp>
+      <p:sp>
+        <p:nvSpPr>
+          <p:cNvPr id="5" name="TextBox 4"/>
+          <p:cNvSpPr txBox="1"/>
+          <p:nvPr/>
+        </p:nvSpPr>
+        <p:spPr>
+          <a:xfrm>
+            <a:off x="11475720" y="6473952"/>
+            <a:ext cx="548640" cy="320040"/>
+          </a:xfrm>
+          <a:prstGeom prst="rect">
+            <a:avLst/>
+          </a:prstGeom>
+          <a:noFill/>
+        </p:spPr>
+        <p:txBody>
+          <a:bodyPr wrap="square">
+            <a:spAutoFit/>
+          </a:bodyPr>
+          <a:lstStyle/>
+          <a:p>
+            <a:pPr algn="r"/>
+            <a:r>
+              <a:rPr sz="1100" b="0">
+                <a:solidFill>
+                  <a:srgbClr val="68707F"/>
+                </a:solidFill>
+                <a:latin typeface="Calibri"/>
+              </a:rPr>
+              <a:t>6</a:t>
             </a:r>
           </a:p>
         </p:txBody>
       </p:sp>
       <p:pic>
         <p:nvPicPr>
-          <p:cNvPr id="3" name="Picture 2" descr="01-home.png"/>
+          <p:cNvPr id="6" name="Picture 5" descr="01-home.png"/>
           <p:cNvPicPr>
             <a:picLocks noChangeAspect="1"/>
           </p:cNvPicPr>
@@ -3649,8 +5075,8 @@
         </p:blipFill>
         <p:spPr>
           <a:xfrm>
-            <a:off x="457200" y="1371600"/>
-            <a:ext cx="5577840" cy="3486150"/>
+            <a:off x="777240" y="1572768"/>
+            <a:ext cx="5440680" cy="3400425"/>
           </a:xfrm>
           <a:prstGeom prst="rect">
             <a:avLst/>
@@ -3659,14 +5085,14 @@
       </p:pic>
       <p:sp>
         <p:nvSpPr>
-          <p:cNvPr id="4" name="TextBox 3"/>
+          <p:cNvPr id="7" name="TextBox 6"/>
           <p:cNvSpPr txBox="1"/>
           <p:nvPr/>
         </p:nvSpPr>
         <p:spPr>
           <a:xfrm>
-            <a:off x="457200" y="4983480"/>
-            <a:ext cx="5577840" cy="457200"/>
+            <a:off x="777240" y="6263640"/>
+            <a:ext cx="5440680" cy="365760"/>
           </a:xfrm>
           <a:prstGeom prst="rect">
             <a:avLst/>
@@ -3674,16 +5100,18 @@
           <a:noFill/>
         </p:spPr>
         <p:txBody>
-          <a:bodyPr wrap="none">
+          <a:bodyPr wrap="square">
             <a:spAutoFit/>
           </a:bodyPr>
           <a:lstStyle/>
           <a:p>
-            <a:r>
-              <a:rPr sz="1300">
+            <a:pPr algn="l"/>
+            <a:r>
+              <a:rPr sz="1200" b="0">
                 <a:solidFill>
                   <a:srgbClr val="68707F"/>
                 </a:solidFill>
+                <a:latin typeface="Calibri"/>
               </a:rPr>
               <a:t>Catalogue public des tests</a:t>
             </a:r>
@@ -3692,7 +5120,7 @@
       </p:sp>
       <p:pic>
         <p:nvPicPr>
-          <p:cNvPr id="5" name="Picture 4" descr="12-login.png"/>
+          <p:cNvPr id="8" name="Picture 7" descr="12-login.png"/>
           <p:cNvPicPr>
             <a:picLocks noChangeAspect="1"/>
           </p:cNvPicPr>
@@ -3706,8 +5134,8 @@
         </p:blipFill>
         <p:spPr>
           <a:xfrm>
-            <a:off x="6263640" y="1371600"/>
-            <a:ext cx="5577840" cy="3486150"/>
+            <a:off x="6446520" y="1572768"/>
+            <a:ext cx="5440680" cy="3400425"/>
           </a:xfrm>
           <a:prstGeom prst="rect">
             <a:avLst/>
@@ -3716,14 +5144,14 @@
       </p:pic>
       <p:sp>
         <p:nvSpPr>
-          <p:cNvPr id="6" name="TextBox 5"/>
+          <p:cNvPr id="9" name="TextBox 8"/>
           <p:cNvSpPr txBox="1"/>
           <p:nvPr/>
         </p:nvSpPr>
         <p:spPr>
           <a:xfrm>
-            <a:off x="6263640" y="4983480"/>
-            <a:ext cx="5577840" cy="457200"/>
+            <a:off x="6446520" y="6263640"/>
+            <a:ext cx="5440680" cy="365760"/>
           </a:xfrm>
           <a:prstGeom prst="rect">
             <a:avLst/>
@@ -3731,16 +5159,18 @@
           <a:noFill/>
         </p:spPr>
         <p:txBody>
-          <a:bodyPr wrap="none">
+          <a:bodyPr wrap="square">
             <a:spAutoFit/>
           </a:bodyPr>
           <a:lstStyle/>
           <a:p>
-            <a:r>
-              <a:rPr sz="1300">
+            <a:pPr algn="l"/>
+            <a:r>
+              <a:rPr sz="1200" b="0">
                 <a:solidFill>
                   <a:srgbClr val="68707F"/>
                 </a:solidFill>
+                <a:latin typeface="Calibri"/>
               </a:rPr>
               <a:t>Connexion pré-remplie (comptes démo)</a:t>
             </a:r>
@@ -3758,6 +5188,14 @@
 <file path=ppt/slides/slide7.xml><?xml version="1.0" encoding="utf-8"?>
 <p:sld xmlns:a="http://schemas.openxmlformats.org/drawingml/2006/main" xmlns:p="http://schemas.openxmlformats.org/presentationml/2006/main" xmlns:r="http://schemas.openxmlformats.org/officeDocument/2006/relationships">
   <p:cSld>
+    <p:bg>
+      <p:bgPr>
+        <a:solidFill>
+          <a:srgbClr val="FBFAF6"/>
+        </a:solidFill>
+        <a:effectLst/>
+      </p:bgPr>
+    </p:bg>
     <p:spTree>
       <p:nvGrpSpPr>
         <p:cNvPr id="1" name=""/>
@@ -3767,14 +5205,58 @@
       <p:grpSpPr/>
       <p:sp>
         <p:nvSpPr>
-          <p:cNvPr id="2" name="TextBox 1"/>
+          <p:cNvPr id="2" name="Rectangle 1"/>
+          <p:cNvSpPr/>
+          <p:nvPr/>
+        </p:nvSpPr>
+        <p:spPr>
+          <a:xfrm>
+            <a:off x="502920" y="0"/>
+            <a:ext cx="32004" cy="6858000"/>
+          </a:xfrm>
+          <a:prstGeom prst="rect">
+            <a:avLst/>
+          </a:prstGeom>
+          <a:solidFill>
+            <a:srgbClr val="D8432F"/>
+          </a:solidFill>
+          <a:ln>
+            <a:noFill/>
+          </a:ln>
+          <a:effectLst/>
+        </p:spPr>
+        <p:style>
+          <a:lnRef idx="1">
+            <a:schemeClr val="accent1"/>
+          </a:lnRef>
+          <a:fillRef idx="3">
+            <a:schemeClr val="accent1"/>
+          </a:fillRef>
+          <a:effectRef idx="2">
+            <a:schemeClr val="accent1"/>
+          </a:effectRef>
+          <a:fontRef idx="minor">
+            <a:schemeClr val="lt1"/>
+          </a:fontRef>
+        </p:style>
+        <p:txBody>
+          <a:bodyPr rtlCol="0" anchor="ctr"/>
+          <a:lstStyle/>
+          <a:p>
+            <a:pPr algn="ctr"/>
+          </a:p>
+        </p:txBody>
+      </p:sp>
+      <p:sp>
+        <p:nvSpPr>
+          <p:cNvPr id="3" name="TextBox 2"/>
           <p:cNvSpPr txBox="1"/>
           <p:nvPr/>
         </p:nvSpPr>
         <p:spPr>
           <a:xfrm>
-            <a:off x="548640" y="320040"/>
-            <a:ext cx="11064240" cy="914400"/>
+            <a:off x="777240" y="292608"/>
+            <a:ext cx="10789920" cy="320040"/>
           </a:xfrm>
           <a:prstGeom prst="rect">
             <a:avLst/>
@@ -3782,25 +5264,97 @@
           <a:noFill/>
         </p:spPr>
         <p:txBody>
-          <a:bodyPr wrap="none">
+          <a:bodyPr wrap="square">
             <a:spAutoFit/>
           </a:bodyPr>
           <a:lstStyle/>
           <a:p>
-            <a:r>
-              <a:rPr sz="3200" b="1">
+            <a:pPr algn="l"/>
+            <a:r>
+              <a:rPr sz="1200" b="1">
+                <a:solidFill>
+                  <a:srgbClr val="D8432F"/>
+                </a:solidFill>
+                <a:latin typeface="Consolas"/>
+              </a:rPr>
+              <a:t>DÉMONSTRATION</a:t>
+            </a:r>
+          </a:p>
+        </p:txBody>
+      </p:sp>
+      <p:sp>
+        <p:nvSpPr>
+          <p:cNvPr id="4" name="TextBox 3"/>
+          <p:cNvSpPr txBox="1"/>
+          <p:nvPr/>
+        </p:nvSpPr>
+        <p:spPr>
+          <a:xfrm>
+            <a:off x="777240" y="566928"/>
+            <a:ext cx="10789920" cy="822960"/>
+          </a:xfrm>
+          <a:prstGeom prst="rect">
+            <a:avLst/>
+          </a:prstGeom>
+          <a:noFill/>
+        </p:spPr>
+        <p:txBody>
+          <a:bodyPr wrap="square">
+            <a:spAutoFit/>
+          </a:bodyPr>
+          <a:lstStyle/>
+          <a:p>
+            <a:pPr algn="l"/>
+            <a:r>
+              <a:rPr sz="3400" b="1">
                 <a:solidFill>
                   <a:srgbClr val="16213A"/>
                 </a:solidFill>
-              </a:rPr>
-              <a:t>Démonstration — Espace administrateur</a:t>
+                <a:latin typeface="Georgia"/>
+              </a:rPr>
+              <a:t>Espace administrateur</a:t>
+            </a:r>
+          </a:p>
+        </p:txBody>
+      </p:sp>
+      <p:sp>
+        <p:nvSpPr>
+          <p:cNvPr id="5" name="TextBox 4"/>
+          <p:cNvSpPr txBox="1"/>
+          <p:nvPr/>
+        </p:nvSpPr>
+        <p:spPr>
+          <a:xfrm>
+            <a:off x="11475720" y="6473952"/>
+            <a:ext cx="548640" cy="320040"/>
+          </a:xfrm>
+          <a:prstGeom prst="rect">
+            <a:avLst/>
+          </a:prstGeom>
+          <a:noFill/>
+        </p:spPr>
+        <p:txBody>
+          <a:bodyPr wrap="square">
+            <a:spAutoFit/>
+          </a:bodyPr>
+          <a:lstStyle/>
+          <a:p>
+            <a:pPr algn="r"/>
+            <a:r>
+              <a:rPr sz="1100" b="0">
+                <a:solidFill>
+                  <a:srgbClr val="68707F"/>
+                </a:solidFill>
+                <a:latin typeface="Calibri"/>
+              </a:rPr>
+              <a:t>7</a:t>
             </a:r>
           </a:p>
         </p:txBody>
       </p:sp>
       <p:pic>
         <p:nvPicPr>
-          <p:cNvPr id="3" name="Picture 2" descr="04-admin-questions.png"/>
+          <p:cNvPr id="6" name="Picture 5" descr="04-admin-questions.png"/>
           <p:cNvPicPr>
             <a:picLocks noChangeAspect="1"/>
           </p:cNvPicPr>
@@ -3814,8 +5368,8 @@
         </p:blipFill>
         <p:spPr>
           <a:xfrm>
-            <a:off x="457200" y="1371600"/>
-            <a:ext cx="5577840" cy="3486150"/>
+            <a:off x="777240" y="1572768"/>
+            <a:ext cx="5440680" cy="3400425"/>
           </a:xfrm>
           <a:prstGeom prst="rect">
             <a:avLst/>
@@ -3824,14 +5378,14 @@
       </p:pic>
       <p:sp>
         <p:nvSpPr>
-          <p:cNvPr id="4" name="TextBox 3"/>
+          <p:cNvPr id="7" name="TextBox 6"/>
           <p:cNvSpPr txBox="1"/>
           <p:nvPr/>
         </p:nvSpPr>
         <p:spPr>
           <a:xfrm>
-            <a:off x="457200" y="4983480"/>
-            <a:ext cx="5577840" cy="457200"/>
+            <a:off x="777240" y="6263640"/>
+            <a:ext cx="5440680" cy="365760"/>
           </a:xfrm>
           <a:prstGeom prst="rect">
             <a:avLst/>
@@ -3839,16 +5393,18 @@
           <a:noFill/>
         </p:spPr>
         <p:txBody>
-          <a:bodyPr wrap="none">
+          <a:bodyPr wrap="square">
             <a:spAutoFit/>
           </a:bodyPr>
           <a:lstStyle/>
           <a:p>
-            <a:r>
-              <a:rPr sz="1300">
+            <a:pPr algn="l"/>
+            <a:r>
+              <a:rPr sz="1200" b="0">
                 <a:solidFill>
                   <a:srgbClr val="68707F"/>
                 </a:solidFill>
+                <a:latin typeface="Calibri"/>
               </a:rPr>
               <a:t>Gestion des questions et options</a:t>
             </a:r>
@@ -3857,7 +5413,7 @@
       </p:sp>
       <p:pic>
         <p:nvPicPr>
-          <p:cNvPr id="5" name="Picture 4" descr="11-admin-results.png"/>
+          <p:cNvPr id="8" name="Picture 7" descr="11-admin-results.png"/>
           <p:cNvPicPr>
             <a:picLocks noChangeAspect="1"/>
           </p:cNvPicPr>
@@ -3871,8 +5427,8 @@
         </p:blipFill>
         <p:spPr>
           <a:xfrm>
-            <a:off x="6263640" y="1371600"/>
-            <a:ext cx="5577840" cy="3486150"/>
+            <a:off x="6446520" y="1572768"/>
+            <a:ext cx="5440680" cy="3400425"/>
           </a:xfrm>
           <a:prstGeom prst="rect">
             <a:avLst/>
@@ -3881,14 +5437,14 @@
       </p:pic>
       <p:sp>
         <p:nvSpPr>
-          <p:cNvPr id="6" name="TextBox 5"/>
+          <p:cNvPr id="9" name="TextBox 8"/>
           <p:cNvSpPr txBox="1"/>
           <p:nvPr/>
         </p:nvSpPr>
         <p:spPr>
           <a:xfrm>
-            <a:off x="6263640" y="4983480"/>
-            <a:ext cx="5577840" cy="457200"/>
+            <a:off x="6446520" y="6263640"/>
+            <a:ext cx="5440680" cy="365760"/>
           </a:xfrm>
           <a:prstGeom prst="rect">
             <a:avLst/>
@@ -3896,16 +5452,18 @@
           <a:noFill/>
         </p:spPr>
         <p:txBody>
-          <a:bodyPr wrap="none">
+          <a:bodyPr wrap="square">
             <a:spAutoFit/>
           </a:bodyPr>
           <a:lstStyle/>
           <a:p>
-            <a:r>
-              <a:rPr sz="1300">
+            <a:pPr algn="l"/>
+            <a:r>
+              <a:rPr sz="1200" b="0">
                 <a:solidFill>
                   <a:srgbClr val="68707F"/>
                 </a:solidFill>
+                <a:latin typeface="Calibri"/>
               </a:rPr>
               <a:t>Tous les résultats</a:t>
             </a:r>
@@ -3923,6 +5481,14 @@
 <file path=ppt/slides/slide8.xml><?xml version="1.0" encoding="utf-8"?>
 <p:sld xmlns:a="http://schemas.openxmlformats.org/drawingml/2006/main" xmlns:p="http://schemas.openxmlformats.org/presentationml/2006/main" xmlns:r="http://schemas.openxmlformats.org/officeDocument/2006/relationships">
   <p:cSld>
+    <p:bg>
+      <p:bgPr>
+        <a:solidFill>
+          <a:srgbClr val="FBFAF6"/>
+        </a:solidFill>
+        <a:effectLst/>
+      </p:bgPr>
+    </p:bg>
     <p:spTree>
       <p:nvGrpSpPr>
         <p:cNvPr id="1" name=""/>
@@ -3932,14 +5498,58 @@
       <p:grpSpPr/>
       <p:sp>
         <p:nvSpPr>
-          <p:cNvPr id="2" name="TextBox 1"/>
+          <p:cNvPr id="2" name="Rectangle 1"/>
+          <p:cNvSpPr/>
+          <p:nvPr/>
+        </p:nvSpPr>
+        <p:spPr>
+          <a:xfrm>
+            <a:off x="502920" y="0"/>
+            <a:ext cx="32004" cy="6858000"/>
+          </a:xfrm>
+          <a:prstGeom prst="rect">
+            <a:avLst/>
+          </a:prstGeom>
+          <a:solidFill>
+            <a:srgbClr val="D8432F"/>
+          </a:solidFill>
+          <a:ln>
+            <a:noFill/>
+          </a:ln>
+          <a:effectLst/>
+        </p:spPr>
+        <p:style>
+          <a:lnRef idx="1">
+            <a:schemeClr val="accent1"/>
+          </a:lnRef>
+          <a:fillRef idx="3">
+            <a:schemeClr val="accent1"/>
+          </a:fillRef>
+          <a:effectRef idx="2">
+            <a:schemeClr val="accent1"/>
+          </a:effectRef>
+          <a:fontRef idx="minor">
+            <a:schemeClr val="lt1"/>
+          </a:fontRef>
+        </p:style>
+        <p:txBody>
+          <a:bodyPr rtlCol="0" anchor="ctr"/>
+          <a:lstStyle/>
+          <a:p>
+            <a:pPr algn="ctr"/>
+          </a:p>
+        </p:txBody>
+      </p:sp>
+      <p:sp>
+        <p:nvSpPr>
+          <p:cNvPr id="3" name="TextBox 2"/>
           <p:cNvSpPr txBox="1"/>
           <p:nvPr/>
         </p:nvSpPr>
         <p:spPr>
           <a:xfrm>
-            <a:off x="548640" y="320040"/>
-            <a:ext cx="11064240" cy="914400"/>
+            <a:off x="777240" y="292608"/>
+            <a:ext cx="10789920" cy="320040"/>
           </a:xfrm>
           <a:prstGeom prst="rect">
             <a:avLst/>
@@ -3947,25 +5557,97 @@
           <a:noFill/>
         </p:spPr>
         <p:txBody>
-          <a:bodyPr wrap="none">
+          <a:bodyPr wrap="square">
             <a:spAutoFit/>
           </a:bodyPr>
           <a:lstStyle/>
           <a:p>
-            <a:r>
-              <a:rPr sz="3200" b="1">
+            <a:pPr algn="l"/>
+            <a:r>
+              <a:rPr sz="1200" b="1">
+                <a:solidFill>
+                  <a:srgbClr val="D8432F"/>
+                </a:solidFill>
+                <a:latin typeface="Consolas"/>
+              </a:rPr>
+              <a:t>DÉMONSTRATION</a:t>
+            </a:r>
+          </a:p>
+        </p:txBody>
+      </p:sp>
+      <p:sp>
+        <p:nvSpPr>
+          <p:cNvPr id="4" name="TextBox 3"/>
+          <p:cNvSpPr txBox="1"/>
+          <p:nvPr/>
+        </p:nvSpPr>
+        <p:spPr>
+          <a:xfrm>
+            <a:off x="777240" y="566928"/>
+            <a:ext cx="10789920" cy="822960"/>
+          </a:xfrm>
+          <a:prstGeom prst="rect">
+            <a:avLst/>
+          </a:prstGeom>
+          <a:noFill/>
+        </p:spPr>
+        <p:txBody>
+          <a:bodyPr wrap="square">
+            <a:spAutoFit/>
+          </a:bodyPr>
+          <a:lstStyle/>
+          <a:p>
+            <a:pPr algn="l"/>
+            <a:r>
+              <a:rPr sz="3400" b="1">
                 <a:solidFill>
                   <a:srgbClr val="16213A"/>
                 </a:solidFill>
-              </a:rPr>
-              <a:t>Démonstration — Passage d'un examen</a:t>
+                <a:latin typeface="Georgia"/>
+              </a:rPr>
+              <a:t>Passage d'un examen</a:t>
+            </a:r>
+          </a:p>
+        </p:txBody>
+      </p:sp>
+      <p:sp>
+        <p:nvSpPr>
+          <p:cNvPr id="5" name="TextBox 4"/>
+          <p:cNvSpPr txBox="1"/>
+          <p:nvPr/>
+        </p:nvSpPr>
+        <p:spPr>
+          <a:xfrm>
+            <a:off x="11475720" y="6473952"/>
+            <a:ext cx="548640" cy="320040"/>
+          </a:xfrm>
+          <a:prstGeom prst="rect">
+            <a:avLst/>
+          </a:prstGeom>
+          <a:noFill/>
+        </p:spPr>
+        <p:txBody>
+          <a:bodyPr wrap="square">
+            <a:spAutoFit/>
+          </a:bodyPr>
+          <a:lstStyle/>
+          <a:p>
+            <a:pPr algn="r"/>
+            <a:r>
+              <a:rPr sz="1100" b="0">
+                <a:solidFill>
+                  <a:srgbClr val="68707F"/>
+                </a:solidFill>
+                <a:latin typeface="Calibri"/>
+              </a:rPr>
+              <a:t>8</a:t>
             </a:r>
           </a:p>
         </p:txBody>
       </p:sp>
       <p:pic>
         <p:nvPicPr>
-          <p:cNvPr id="3" name="Picture 2" descr="06-take-test.png"/>
+          <p:cNvPr id="6" name="Picture 5" descr="06-take-test.png"/>
           <p:cNvPicPr>
             <a:picLocks noChangeAspect="1"/>
           </p:cNvPicPr>
@@ -3979,8 +5661,8 @@
         </p:blipFill>
         <p:spPr>
           <a:xfrm>
-            <a:off x="457200" y="1371600"/>
-            <a:ext cx="5577840" cy="3486150"/>
+            <a:off x="777240" y="1572768"/>
+            <a:ext cx="5440680" cy="3400425"/>
           </a:xfrm>
           <a:prstGeom prst="rect">
             <a:avLst/>
@@ -3989,14 +5671,14 @@
       </p:pic>
       <p:sp>
         <p:nvSpPr>
-          <p:cNvPr id="4" name="TextBox 3"/>
+          <p:cNvPr id="7" name="TextBox 6"/>
           <p:cNvSpPr txBox="1"/>
           <p:nvPr/>
         </p:nvSpPr>
         <p:spPr>
           <a:xfrm>
-            <a:off x="457200" y="4983480"/>
-            <a:ext cx="5577840" cy="457200"/>
+            <a:off x="777240" y="6263640"/>
+            <a:ext cx="5440680" cy="365760"/>
           </a:xfrm>
           <a:prstGeom prst="rect">
             <a:avLst/>
@@ -4004,16 +5686,18 @@
           <a:noFill/>
         </p:spPr>
         <p:txBody>
-          <a:bodyPr wrap="none">
+          <a:bodyPr wrap="square">
             <a:spAutoFit/>
           </a:bodyPr>
           <a:lstStyle/>
           <a:p>
-            <a:r>
-              <a:rPr sz="1300">
+            <a:pPr algn="l"/>
+            <a:r>
+              <a:rPr sz="1200" b="0">
                 <a:solidFill>
                   <a:srgbClr val="68707F"/>
                 </a:solidFill>
+                <a:latin typeface="Calibri"/>
               </a:rPr>
               <a:t>Examen chronométré, questions aléatoires</a:t>
             </a:r>
@@ -4022,7 +5706,7 @@
       </p:sp>
       <p:pic>
         <p:nvPicPr>
-          <p:cNvPr id="5" name="Picture 4" descr="07-result.png"/>
+          <p:cNvPr id="8" name="Picture 7" descr="07-result.png"/>
           <p:cNvPicPr>
             <a:picLocks noChangeAspect="1"/>
           </p:cNvPicPr>
@@ -4036,8 +5720,8 @@
         </p:blipFill>
         <p:spPr>
           <a:xfrm>
-            <a:off x="6263640" y="1371600"/>
-            <a:ext cx="5577840" cy="3486150"/>
+            <a:off x="6446520" y="1572768"/>
+            <a:ext cx="5440680" cy="3400425"/>
           </a:xfrm>
           <a:prstGeom prst="rect">
             <a:avLst/>
@@ -4046,14 +5730,14 @@
       </p:pic>
       <p:sp>
         <p:nvSpPr>
-          <p:cNvPr id="6" name="TextBox 5"/>
+          <p:cNvPr id="9" name="TextBox 8"/>
           <p:cNvSpPr txBox="1"/>
           <p:nvPr/>
         </p:nvSpPr>
         <p:spPr>
           <a:xfrm>
-            <a:off x="6263640" y="4983480"/>
-            <a:ext cx="5577840" cy="457200"/>
+            <a:off x="6446520" y="6263640"/>
+            <a:ext cx="5440680" cy="365760"/>
           </a:xfrm>
           <a:prstGeom prst="rect">
             <a:avLst/>
@@ -4061,16 +5745,18 @@
           <a:noFill/>
         </p:spPr>
         <p:txBody>
-          <a:bodyPr wrap="none">
+          <a:bodyPr wrap="square">
             <a:spAutoFit/>
           </a:bodyPr>
           <a:lstStyle/>
           <a:p>
-            <a:r>
-              <a:rPr sz="1300">
+            <a:pPr algn="l"/>
+            <a:r>
+              <a:rPr sz="1200" b="0">
                 <a:solidFill>
                   <a:srgbClr val="68707F"/>
                 </a:solidFill>
+                <a:latin typeface="Calibri"/>
               </a:rPr>
               <a:t>Copie rendue : score immédiat</a:t>
             </a:r>
@@ -4088,6 +5774,14 @@
 <file path=ppt/slides/slide9.xml><?xml version="1.0" encoding="utf-8"?>
 <p:sld xmlns:a="http://schemas.openxmlformats.org/drawingml/2006/main" xmlns:p="http://schemas.openxmlformats.org/presentationml/2006/main" xmlns:r="http://schemas.openxmlformats.org/officeDocument/2006/relationships">
   <p:cSld>
+    <p:bg>
+      <p:bgPr>
+        <a:solidFill>
+          <a:srgbClr val="16213A"/>
+        </a:solidFill>
+        <a:effectLst/>
+      </p:bgPr>
+    </p:bg>
     <p:spTree>
       <p:nvGrpSpPr>
         <p:cNvPr id="1" name=""/>
@@ -4097,34 +5791,45 @@
       <p:grpSpPr/>
       <p:sp>
         <p:nvSpPr>
-          <p:cNvPr id="2" name="TextBox 1"/>
-          <p:cNvSpPr txBox="1"/>
-          <p:nvPr/>
-        </p:nvSpPr>
-        <p:spPr>
-          <a:xfrm>
-            <a:off x="548640" y="320040"/>
-            <a:ext cx="11064240" cy="914400"/>
-          </a:xfrm>
-          <a:prstGeom prst="rect">
-            <a:avLst/>
-          </a:prstGeom>
-          <a:noFill/>
-        </p:spPr>
-        <p:txBody>
-          <a:bodyPr wrap="none">
-            <a:spAutoFit/>
-          </a:bodyPr>
-          <a:lstStyle/>
-          <a:p>
-            <a:r>
-              <a:rPr sz="3200" b="1">
-                <a:solidFill>
-                  <a:srgbClr val="16213A"/>
-                </a:solidFill>
-              </a:rPr>
-              <a:t>Conclusion</a:t>
-            </a:r>
+          <p:cNvPr id="2" name="Rectangle 1"/>
+          <p:cNvSpPr/>
+          <p:nvPr/>
+        </p:nvSpPr>
+        <p:spPr>
+          <a:xfrm>
+            <a:off x="502920" y="0"/>
+            <a:ext cx="32004" cy="6858000"/>
+          </a:xfrm>
+          <a:prstGeom prst="rect">
+            <a:avLst/>
+          </a:prstGeom>
+          <a:solidFill>
+            <a:srgbClr val="D8432F"/>
+          </a:solidFill>
+          <a:ln>
+            <a:noFill/>
+          </a:ln>
+          <a:effectLst/>
+        </p:spPr>
+        <p:style>
+          <a:lnRef idx="1">
+            <a:schemeClr val="accent1"/>
+          </a:lnRef>
+          <a:fillRef idx="3">
+            <a:schemeClr val="accent1"/>
+          </a:fillRef>
+          <a:effectRef idx="2">
+            <a:schemeClr val="accent1"/>
+          </a:effectRef>
+          <a:fontRef idx="minor">
+            <a:schemeClr val="lt1"/>
+          </a:fontRef>
+        </p:style>
+        <p:txBody>
+          <a:bodyPr rtlCol="0" anchor="ctr"/>
+          <a:lstStyle/>
+          <a:p>
+            <a:pPr algn="ctr"/>
           </a:p>
         </p:txBody>
       </p:sp>
@@ -4136,8 +5841,8 @@
         </p:nvSpPr>
         <p:spPr>
           <a:xfrm>
-            <a:off x="731520" y="1463040"/>
-            <a:ext cx="10698480" cy="4937760"/>
+            <a:off x="914400" y="502920"/>
+            <a:ext cx="10515600" cy="365760"/>
           </a:xfrm>
           <a:prstGeom prst="rect">
             <a:avLst/>
@@ -4150,63 +5855,203 @@
           </a:bodyPr>
           <a:lstStyle/>
           <a:p>
+            <a:pPr algn="l"/>
+            <a:r>
+              <a:rPr sz="1200" b="1">
+                <a:solidFill>
+                  <a:srgbClr val="D8432F"/>
+                </a:solidFill>
+                <a:latin typeface="Consolas"/>
+              </a:rPr>
+              <a:t>CONCLUSION</a:t>
+            </a:r>
+          </a:p>
+        </p:txBody>
+      </p:sp>
+      <p:sp>
+        <p:nvSpPr>
+          <p:cNvPr id="4" name="TextBox 3"/>
+          <p:cNvSpPr txBox="1"/>
+          <p:nvPr/>
+        </p:nvSpPr>
+        <p:spPr>
+          <a:xfrm>
+            <a:off x="914400" y="868680"/>
+            <a:ext cx="10515600" cy="822960"/>
+          </a:xfrm>
+          <a:prstGeom prst="rect">
+            <a:avLst/>
+          </a:prstGeom>
+          <a:noFill/>
+        </p:spPr>
+        <p:txBody>
+          <a:bodyPr wrap="square">
+            <a:spAutoFit/>
+          </a:bodyPr>
+          <a:lstStyle/>
+          <a:p>
+            <a:pPr algn="l"/>
+            <a:r>
+              <a:rPr sz="3400" b="1">
+                <a:solidFill>
+                  <a:srgbClr val="FFFFFF"/>
+                </a:solidFill>
+                <a:latin typeface="Georgia"/>
+              </a:rPr>
+              <a:t>Un cycle d'examen couvert de bout en bout</a:t>
+            </a:r>
+          </a:p>
+        </p:txBody>
+      </p:sp>
+      <p:sp>
+        <p:nvSpPr>
+          <p:cNvPr id="5" name="TextBox 4"/>
+          <p:cNvSpPr txBox="1"/>
+          <p:nvPr/>
+        </p:nvSpPr>
+        <p:spPr>
+          <a:xfrm>
+            <a:off x="960120" y="2011680"/>
+            <a:ext cx="10332720" cy="3291840"/>
+          </a:xfrm>
+          <a:prstGeom prst="rect">
+            <a:avLst/>
+          </a:prstGeom>
+          <a:noFill/>
+        </p:spPr>
+        <p:txBody>
+          <a:bodyPr wrap="square">
+            <a:spAutoFit/>
+          </a:bodyPr>
+          <a:lstStyle/>
+          <a:p>
             <a:pPr>
               <a:spcAft>
-                <a:spcPts val="1000"/>
+                <a:spcPts val="1400"/>
               </a:spcAft>
             </a:pPr>
             <a:r>
-              <a:rPr sz="2000">
-                <a:solidFill>
-                  <a:srgbClr val="16213A"/>
-                </a:solidFill>
-              </a:rPr>
-              <a:t>•  Architecture propre en couches distinctes, conforme aux exigences du module.</a:t>
+              <a:rPr sz="1800">
+                <a:solidFill>
+                  <a:srgbClr val="C3CBDD"/>
+                </a:solidFill>
+              </a:rPr>
+              <a:t>✓  Architecture en couches conforme aux exigences du module — web, métier (interfaces + impl), DAO, sécurité transversale.</a:t>
             </a:r>
           </a:p>
           <a:p>
             <a:pPr>
               <a:spcAft>
-                <a:spcPts val="1000"/>
+                <a:spcPts val="1400"/>
               </a:spcAft>
             </a:pPr>
             <a:r>
-              <a:rPr sz="2000">
-                <a:solidFill>
-                  <a:srgbClr val="16213A"/>
-                </a:solidFill>
-              </a:rPr>
-              <a:t>•  Stack moderne : Spring Boot 3.5, Spring Data JPA, Spring Security 6 + JWT, React 19.</a:t>
+              <a:rPr sz="1800">
+                <a:solidFill>
+                  <a:srgbClr val="C3CBDD"/>
+                </a:solidFill>
+              </a:rPr>
+              <a:t>✓  Stack moderne : Spring Boot 3.5, Spring Data JPA, Spring Security 6 + JWT, React 19.</a:t>
             </a:r>
           </a:p>
           <a:p>
             <a:pPr>
               <a:spcAft>
-                <a:spcPts val="1000"/>
+                <a:spcPts val="1400"/>
               </a:spcAft>
             </a:pPr>
             <a:r>
-              <a:rPr sz="2000">
-                <a:solidFill>
-                  <a:srgbClr val="16213A"/>
-                </a:solidFill>
-              </a:rPr>
-              <a:t>•  CRUD complet sur 11 entités en relation, workflow d'examen de bout en bout, règles métier protégées.</a:t>
+              <a:rPr sz="1800">
+                <a:solidFill>
+                  <a:srgbClr val="C3CBDD"/>
+                </a:solidFill>
+              </a:rPr>
+              <a:t>✓  CRUD complet sur 11 entités, règles métier protégées, notation automatique vérifiée.</a:t>
             </a:r>
           </a:p>
           <a:p>
             <a:pPr>
               <a:spcAft>
-                <a:spcPts val="1000"/>
+                <a:spcPts val="1400"/>
               </a:spcAft>
             </a:pPr>
             <a:r>
-              <a:rPr sz="2000">
-                <a:solidFill>
-                  <a:srgbClr val="16213A"/>
-                </a:solidFill>
-              </a:rPr>
-              <a:t>•  Perspectives : notifications e-mail, types de questions supplémentaires, statistiques avancées, déploiement cloud.</a:t>
+              <a:rPr sz="1800">
+                <a:solidFill>
+                  <a:srgbClr val="C3CBDD"/>
+                </a:solidFill>
+              </a:rPr>
+              <a:t>✓  Perspectives : notifications e-mail, nouveaux types de questions, statistiques, déploiement cloud.</a:t>
+            </a:r>
+          </a:p>
+        </p:txBody>
+      </p:sp>
+      <p:sp>
+        <p:nvSpPr>
+          <p:cNvPr id="6" name="TextBox 5"/>
+          <p:cNvSpPr txBox="1"/>
+          <p:nvPr/>
+        </p:nvSpPr>
+        <p:spPr>
+          <a:xfrm>
+            <a:off x="960120" y="5760720"/>
+            <a:ext cx="10332720" cy="457200"/>
+          </a:xfrm>
+          <a:prstGeom prst="rect">
+            <a:avLst/>
+          </a:prstGeom>
+          <a:noFill/>
+        </p:spPr>
+        <p:txBody>
+          <a:bodyPr wrap="square">
+            <a:spAutoFit/>
+          </a:bodyPr>
+          <a:lstStyle/>
+          <a:p>
+            <a:pPr algn="l"/>
+            <a:r>
+              <a:rPr sz="1500" b="0">
+                <a:solidFill>
+                  <a:srgbClr val="FFFFFF"/>
+                </a:solidFill>
+                <a:latin typeface="Calibri"/>
+              </a:rPr>
+              <a:t>Code source : github.com/mehdiaichouch2002/echallenge</a:t>
+            </a:r>
+          </a:p>
+        </p:txBody>
+      </p:sp>
+      <p:sp>
+        <p:nvSpPr>
+          <p:cNvPr id="7" name="TextBox 6"/>
+          <p:cNvSpPr txBox="1"/>
+          <p:nvPr/>
+        </p:nvSpPr>
+        <p:spPr>
+          <a:xfrm>
+            <a:off x="11475720" y="6473952"/>
+            <a:ext cx="548640" cy="320040"/>
+          </a:xfrm>
+          <a:prstGeom prst="rect">
+            <a:avLst/>
+          </a:prstGeom>
+          <a:noFill/>
+        </p:spPr>
+        <p:txBody>
+          <a:bodyPr wrap="square">
+            <a:spAutoFit/>
+          </a:bodyPr>
+          <a:lstStyle/>
+          <a:p>
+            <a:pPr algn="r"/>
+            <a:r>
+              <a:rPr sz="1100" b="0">
+                <a:solidFill>
+                  <a:srgbClr val="C3CBDD"/>
+                </a:solidFill>
+                <a:latin typeface="Calibri"/>
+              </a:rPr>
+              <a:t>9</a:t>
             </a:r>
           </a:p>
         </p:txBody>

</xml_diff>